<commit_message>
feat: Add native draw.io XML diagrams, visual architecture slide, and published baseline results in Review 2 PPT
</commit_message>
<xml_diff>
--- a/SDP_Review2_Presentation.pptx
+++ b/SDP_Review2_Presentation.pptx
@@ -16,7 +16,6 @@
     <p:sldId id="264" r:id="rId12"/>
     <p:sldId id="265" r:id="rId13"/>
     <p:sldId id="266" r:id="rId14"/>
-    <p:sldId id="267" r:id="rId15"/>
   </p:sldIdLst>
   <p:sldSz cx="9144000" cy="5143500"/>
   <p:notesSz cx="6858000" cy="9144000"/>
@@ -5996,1129 +5995,12 @@
               </a:defRPr>
             </a:pPr>
             <a:r>
-              <a:t>Experimental Results — 4-Way Benchmark</a:t>
-            </a:r>
-          </a:p>
-          <a:p>
-            <a:pPr>
-              <a:defRPr sz="1000" b="1">
-                <a:solidFill>
-                  <a:srgbClr val="1A5FB4"/>
-                </a:solidFill>
-                <a:latin typeface="Arial"/>
-              </a:defRPr>
-            </a:pPr>
-            <a:r>
-              <a:t>PI 3.3.1 / 12.1.2: MULTI-CENTER NON-IID HRCT COHORT EVALUATION</a:t>
-            </a:r>
-          </a:p>
-        </p:txBody>
-      </p:sp>
-      <p:graphicFrame>
-        <p:nvGraphicFramePr>
-          <p:cNvPr id="5" name="Table 4"/>
-          <p:cNvGraphicFramePr>
-            <a:graphicFrameLocks noGrp="1"/>
-          </p:cNvGraphicFramePr>
-          <p:nvPr/>
-        </p:nvGraphicFramePr>
-        <p:xfrm>
-          <a:off x="320040" y="841248"/>
-          <a:ext cx="8503920" cy="2011680"/>
-        </p:xfrm>
-        <a:graphic>
-          <a:graphicData uri="http://schemas.openxmlformats.org/drawingml/2006/table">
-            <a:tbl>
-              <a:tblPr firstRow="1" bandRow="1">
-                <a:tableStyleId>{5C22544A-7EE6-4342-B048-85BDC9FD1C3A}</a:tableStyleId>
-              </a:tblPr>
-              <a:tblGrid>
-                <a:gridCol w="1214845"/>
-                <a:gridCol w="1214845"/>
-                <a:gridCol w="1214845"/>
-                <a:gridCol w="1214845"/>
-                <a:gridCol w="1214845"/>
-                <a:gridCol w="1214845"/>
-                <a:gridCol w="1214850"/>
-              </a:tblGrid>
-              <a:tr h="402336">
-                <a:tc>
-                  <a:txBody>
-                    <a:bodyPr/>
-                    <a:lstStyle/>
-                    <a:p>
-                      <a:pPr algn="ctr">
-                        <a:defRPr sz="1100" b="1">
-                          <a:solidFill>
-                            <a:srgbClr val="FFFFFF"/>
-                          </a:solidFill>
-                          <a:latin typeface="Arial"/>
-                        </a:defRPr>
-                      </a:pPr>
-                      <a:r>
-                        <a:t>Method</a:t>
-                      </a:r>
-                    </a:p>
-                  </a:txBody>
-                  <a:tcPr>
-                    <a:solidFill>
-                      <a:srgbClr val="0A2540"/>
-                    </a:solidFill>
-                  </a:tcPr>
-                </a:tc>
-                <a:tc>
-                  <a:txBody>
-                    <a:bodyPr/>
-                    <a:lstStyle/>
-                    <a:p>
-                      <a:pPr algn="ctr">
-                        <a:defRPr sz="1100" b="1">
-                          <a:solidFill>
-                            <a:srgbClr val="FFFFFF"/>
-                          </a:solidFill>
-                          <a:latin typeface="Arial"/>
-                        </a:defRPr>
-                      </a:pPr>
-                      <a:r>
-                        <a:t>Balanced Acc</a:t>
-                      </a:r>
-                    </a:p>
-                  </a:txBody>
-                  <a:tcPr>
-                    <a:solidFill>
-                      <a:srgbClr val="0A2540"/>
-                    </a:solidFill>
-                  </a:tcPr>
-                </a:tc>
-                <a:tc>
-                  <a:txBody>
-                    <a:bodyPr/>
-                    <a:lstStyle/>
-                    <a:p>
-                      <a:pPr algn="ctr">
-                        <a:defRPr sz="1100" b="1">
-                          <a:solidFill>
-                            <a:srgbClr val="FFFFFF"/>
-                          </a:solidFill>
-                          <a:latin typeface="Arial"/>
-                        </a:defRPr>
-                      </a:pPr>
-                      <a:r>
-                        <a:t>IPF Recall (Sens.)</a:t>
-                      </a:r>
-                    </a:p>
-                  </a:txBody>
-                  <a:tcPr>
-                    <a:solidFill>
-                      <a:srgbClr val="0A2540"/>
-                    </a:solidFill>
-                  </a:tcPr>
-                </a:tc>
-                <a:tc>
-                  <a:txBody>
-                    <a:bodyPr/>
-                    <a:lstStyle/>
-                    <a:p>
-                      <a:pPr algn="ctr">
-                        <a:defRPr sz="1100" b="1">
-                          <a:solidFill>
-                            <a:srgbClr val="FFFFFF"/>
-                          </a:solidFill>
-                          <a:latin typeface="Arial"/>
-                        </a:defRPr>
-                      </a:pPr>
-                      <a:r>
-                        <a:t>IPF Precision</a:t>
-                      </a:r>
-                    </a:p>
-                  </a:txBody>
-                  <a:tcPr>
-                    <a:solidFill>
-                      <a:srgbClr val="0A2540"/>
-                    </a:solidFill>
-                  </a:tcPr>
-                </a:tc>
-                <a:tc>
-                  <a:txBody>
-                    <a:bodyPr/>
-                    <a:lstStyle/>
-                    <a:p>
-                      <a:pPr algn="ctr">
-                        <a:defRPr sz="1100" b="1">
-                          <a:solidFill>
-                            <a:srgbClr val="FFFFFF"/>
-                          </a:solidFill>
-                          <a:latin typeface="Arial"/>
-                        </a:defRPr>
-                      </a:pPr>
-                      <a:r>
-                        <a:t>IPF F1-Score</a:t>
-                      </a:r>
-                    </a:p>
-                  </a:txBody>
-                  <a:tcPr>
-                    <a:solidFill>
-                      <a:srgbClr val="0A2540"/>
-                    </a:solidFill>
-                  </a:tcPr>
-                </a:tc>
-                <a:tc>
-                  <a:txBody>
-                    <a:bodyPr/>
-                    <a:lstStyle/>
-                    <a:p>
-                      <a:pPr algn="ctr">
-                        <a:defRPr sz="1100" b="1">
-                          <a:solidFill>
-                            <a:srgbClr val="FFFFFF"/>
-                          </a:solidFill>
-                          <a:latin typeface="Arial"/>
-                        </a:defRPr>
-                      </a:pPr>
-                      <a:r>
-                        <a:t>Macro-F1</a:t>
-                      </a:r>
-                    </a:p>
-                  </a:txBody>
-                  <a:tcPr>
-                    <a:solidFill>
-                      <a:srgbClr val="0A2540"/>
-                    </a:solidFill>
-                  </a:tcPr>
-                </a:tc>
-                <a:tc>
-                  <a:txBody>
-                    <a:bodyPr/>
-                    <a:lstStyle/>
-                    <a:p>
-                      <a:pPr algn="ctr">
-                        <a:defRPr sz="1100" b="1">
-                          <a:solidFill>
-                            <a:srgbClr val="FFFFFF"/>
-                          </a:solidFill>
-                          <a:latin typeface="Arial"/>
-                        </a:defRPr>
-                      </a:pPr>
-                      <a:r>
-                        <a:t>Overall Acc</a:t>
-                      </a:r>
-                    </a:p>
-                  </a:txBody>
-                  <a:tcPr>
-                    <a:solidFill>
-                      <a:srgbClr val="0A2540"/>
-                    </a:solidFill>
-                  </a:tcPr>
-                </a:tc>
-              </a:tr>
-              <a:tr h="402336">
-                <a:tc>
-                  <a:txBody>
-                    <a:bodyPr/>
-                    <a:lstStyle/>
-                    <a:p>
-                      <a:pPr algn="l">
-                        <a:defRPr sz="1050" b="0">
-                          <a:solidFill>
-                            <a:srgbClr val="282C34"/>
-                          </a:solidFill>
-                          <a:latin typeface="Arial"/>
-                        </a:defRPr>
-                      </a:pPr>
-                      <a:r>
-                        <a:t>FedAvg (Vanilla '17)</a:t>
-                      </a:r>
-                    </a:p>
-                  </a:txBody>
-                  <a:tcPr>
-                    <a:solidFill>
-                      <a:srgbClr val="FFFFFF"/>
-                    </a:solidFill>
-                  </a:tcPr>
-                </a:tc>
-                <a:tc>
-                  <a:txBody>
-                    <a:bodyPr/>
-                    <a:lstStyle/>
-                    <a:p>
-                      <a:pPr algn="ctr">
-                        <a:defRPr sz="1050" b="0">
-                          <a:solidFill>
-                            <a:srgbClr val="282C34"/>
-                          </a:solidFill>
-                          <a:latin typeface="Arial"/>
-                        </a:defRPr>
-                      </a:pPr>
-                      <a:r>
-                        <a:t>48.6%</a:t>
-                      </a:r>
-                    </a:p>
-                  </a:txBody>
-                  <a:tcPr>
-                    <a:solidFill>
-                      <a:srgbClr val="FFFFFF"/>
-                    </a:solidFill>
-                  </a:tcPr>
-                </a:tc>
-                <a:tc>
-                  <a:txBody>
-                    <a:bodyPr/>
-                    <a:lstStyle/>
-                    <a:p>
-                      <a:pPr algn="ctr">
-                        <a:defRPr sz="1050" b="0">
-                          <a:solidFill>
-                            <a:srgbClr val="282C34"/>
-                          </a:solidFill>
-                          <a:latin typeface="Arial"/>
-                        </a:defRPr>
-                      </a:pPr>
-                      <a:r>
-                        <a:t>19.0%</a:t>
-                      </a:r>
-                    </a:p>
-                  </a:txBody>
-                  <a:tcPr>
-                    <a:solidFill>
-                      <a:srgbClr val="FFFFFF"/>
-                    </a:solidFill>
-                  </a:tcPr>
-                </a:tc>
-                <a:tc>
-                  <a:txBody>
-                    <a:bodyPr/>
-                    <a:lstStyle/>
-                    <a:p>
-                      <a:pPr algn="ctr">
-                        <a:defRPr sz="1050" b="0">
-                          <a:solidFill>
-                            <a:srgbClr val="282C34"/>
-                          </a:solidFill>
-                          <a:latin typeface="Arial"/>
-                        </a:defRPr>
-                      </a:pPr>
-                      <a:r>
-                        <a:t>33.3%</a:t>
-                      </a:r>
-                    </a:p>
-                  </a:txBody>
-                  <a:tcPr>
-                    <a:solidFill>
-                      <a:srgbClr val="FFFFFF"/>
-                    </a:solidFill>
-                  </a:tcPr>
-                </a:tc>
-                <a:tc>
-                  <a:txBody>
-                    <a:bodyPr/>
-                    <a:lstStyle/>
-                    <a:p>
-                      <a:pPr algn="ctr">
-                        <a:defRPr sz="1050" b="0">
-                          <a:solidFill>
-                            <a:srgbClr val="282C34"/>
-                          </a:solidFill>
-                          <a:latin typeface="Arial"/>
-                        </a:defRPr>
-                      </a:pPr>
-                      <a:r>
-                        <a:t>24.2%</a:t>
-                      </a:r>
-                    </a:p>
-                  </a:txBody>
-                  <a:tcPr>
-                    <a:solidFill>
-                      <a:srgbClr val="FFFFFF"/>
-                    </a:solidFill>
-                  </a:tcPr>
-                </a:tc>
-                <a:tc>
-                  <a:txBody>
-                    <a:bodyPr/>
-                    <a:lstStyle/>
-                    <a:p>
-                      <a:pPr algn="ctr">
-                        <a:defRPr sz="1050" b="0">
-                          <a:solidFill>
-                            <a:srgbClr val="282C34"/>
-                          </a:solidFill>
-                          <a:latin typeface="Arial"/>
-                        </a:defRPr>
-                      </a:pPr>
-                      <a:r>
-                        <a:t>45.1%</a:t>
-                      </a:r>
-                    </a:p>
-                  </a:txBody>
-                  <a:tcPr>
-                    <a:solidFill>
-                      <a:srgbClr val="FFFFFF"/>
-                    </a:solidFill>
-                  </a:tcPr>
-                </a:tc>
-                <a:tc>
-                  <a:txBody>
-                    <a:bodyPr/>
-                    <a:lstStyle/>
-                    <a:p>
-                      <a:pPr algn="ctr">
-                        <a:defRPr sz="1050" b="0">
-                          <a:solidFill>
-                            <a:srgbClr val="282C34"/>
-                          </a:solidFill>
-                          <a:latin typeface="Arial"/>
-                        </a:defRPr>
-                      </a:pPr>
-                      <a:r>
-                        <a:t>68.5%</a:t>
-                      </a:r>
-                    </a:p>
-                  </a:txBody>
-                  <a:tcPr>
-                    <a:solidFill>
-                      <a:srgbClr val="FFFFFF"/>
-                    </a:solidFill>
-                  </a:tcPr>
-                </a:tc>
-              </a:tr>
-              <a:tr h="402336">
-                <a:tc>
-                  <a:txBody>
-                    <a:bodyPr/>
-                    <a:lstStyle/>
-                    <a:p>
-                      <a:pPr algn="l">
-                        <a:defRPr sz="1050" b="0">
-                          <a:solidFill>
-                            <a:srgbClr val="282C34"/>
-                          </a:solidFill>
-                          <a:latin typeface="Arial"/>
-                        </a:defRPr>
-                      </a:pPr>
-                      <a:r>
-                        <a:t>FedProx (mu=0.01)</a:t>
-                      </a:r>
-                    </a:p>
-                  </a:txBody>
-                  <a:tcPr>
-                    <a:solidFill>
-                      <a:srgbClr val="F5F7FA"/>
-                    </a:solidFill>
-                  </a:tcPr>
-                </a:tc>
-                <a:tc>
-                  <a:txBody>
-                    <a:bodyPr/>
-                    <a:lstStyle/>
-                    <a:p>
-                      <a:pPr algn="ctr">
-                        <a:defRPr sz="1050" b="0">
-                          <a:solidFill>
-                            <a:srgbClr val="282C34"/>
-                          </a:solidFill>
-                          <a:latin typeface="Arial"/>
-                        </a:defRPr>
-                      </a:pPr>
-                      <a:r>
-                        <a:t>54.2%</a:t>
-                      </a:r>
-                    </a:p>
-                  </a:txBody>
-                  <a:tcPr>
-                    <a:solidFill>
-                      <a:srgbClr val="F5F7FA"/>
-                    </a:solidFill>
-                  </a:tcPr>
-                </a:tc>
-                <a:tc>
-                  <a:txBody>
-                    <a:bodyPr/>
-                    <a:lstStyle/>
-                    <a:p>
-                      <a:pPr algn="ctr">
-                        <a:defRPr sz="1050" b="0">
-                          <a:solidFill>
-                            <a:srgbClr val="282C34"/>
-                          </a:solidFill>
-                          <a:latin typeface="Arial"/>
-                        </a:defRPr>
-                      </a:pPr>
-                      <a:r>
-                        <a:t>38.1%</a:t>
-                      </a:r>
-                    </a:p>
-                  </a:txBody>
-                  <a:tcPr>
-                    <a:solidFill>
-                      <a:srgbClr val="F5F7FA"/>
-                    </a:solidFill>
-                  </a:tcPr>
-                </a:tc>
-                <a:tc>
-                  <a:txBody>
-                    <a:bodyPr/>
-                    <a:lstStyle/>
-                    <a:p>
-                      <a:pPr algn="ctr">
-                        <a:defRPr sz="1050" b="0">
-                          <a:solidFill>
-                            <a:srgbClr val="282C34"/>
-                          </a:solidFill>
-                          <a:latin typeface="Arial"/>
-                        </a:defRPr>
-                      </a:pPr>
-                      <a:r>
-                        <a:t>47.1%</a:t>
-                      </a:r>
-                    </a:p>
-                  </a:txBody>
-                  <a:tcPr>
-                    <a:solidFill>
-                      <a:srgbClr val="F5F7FA"/>
-                    </a:solidFill>
-                  </a:tcPr>
-                </a:tc>
-                <a:tc>
-                  <a:txBody>
-                    <a:bodyPr/>
-                    <a:lstStyle/>
-                    <a:p>
-                      <a:pPr algn="ctr">
-                        <a:defRPr sz="1050" b="0">
-                          <a:solidFill>
-                            <a:srgbClr val="282C34"/>
-                          </a:solidFill>
-                          <a:latin typeface="Arial"/>
-                        </a:defRPr>
-                      </a:pPr>
-                      <a:r>
-                        <a:t>42.1%</a:t>
-                      </a:r>
-                    </a:p>
-                  </a:txBody>
-                  <a:tcPr>
-                    <a:solidFill>
-                      <a:srgbClr val="F5F7FA"/>
-                    </a:solidFill>
-                  </a:tcPr>
-                </a:tc>
-                <a:tc>
-                  <a:txBody>
-                    <a:bodyPr/>
-                    <a:lstStyle/>
-                    <a:p>
-                      <a:pPr algn="ctr">
-                        <a:defRPr sz="1050" b="0">
-                          <a:solidFill>
-                            <a:srgbClr val="282C34"/>
-                          </a:solidFill>
-                          <a:latin typeface="Arial"/>
-                        </a:defRPr>
-                      </a:pPr>
-                      <a:r>
-                        <a:t>52.8%</a:t>
-                      </a:r>
-                    </a:p>
-                  </a:txBody>
-                  <a:tcPr>
-                    <a:solidFill>
-                      <a:srgbClr val="F5F7FA"/>
-                    </a:solidFill>
-                  </a:tcPr>
-                </a:tc>
-                <a:tc>
-                  <a:txBody>
-                    <a:bodyPr/>
-                    <a:lstStyle/>
-                    <a:p>
-                      <a:pPr algn="ctr">
-                        <a:defRPr sz="1050" b="0">
-                          <a:solidFill>
-                            <a:srgbClr val="282C34"/>
-                          </a:solidFill>
-                          <a:latin typeface="Arial"/>
-                        </a:defRPr>
-                      </a:pPr>
-                      <a:r>
-                        <a:t>71.0%</a:t>
-                      </a:r>
-                    </a:p>
-                  </a:txBody>
-                  <a:tcPr>
-                    <a:solidFill>
-                      <a:srgbClr val="F5F7FA"/>
-                    </a:solidFill>
-                  </a:tcPr>
-                </a:tc>
-              </a:tr>
-              <a:tr h="402336">
-                <a:tc>
-                  <a:txBody>
-                    <a:bodyPr/>
-                    <a:lstStyle/>
-                    <a:p>
-                      <a:pPr algn="l">
-                        <a:defRPr sz="1050" b="0">
-                          <a:solidFill>
-                            <a:srgbClr val="282C34"/>
-                          </a:solidFill>
-                          <a:latin typeface="Arial"/>
-                        </a:defRPr>
-                      </a:pPr>
-                      <a:r>
-                        <a:t>FedIIC (MICCAI '23)</a:t>
-                      </a:r>
-                    </a:p>
-                  </a:txBody>
-                  <a:tcPr>
-                    <a:solidFill>
-                      <a:srgbClr val="FFFFFF"/>
-                    </a:solidFill>
-                  </a:tcPr>
-                </a:tc>
-                <a:tc>
-                  <a:txBody>
-                    <a:bodyPr/>
-                    <a:lstStyle/>
-                    <a:p>
-                      <a:pPr algn="ctr">
-                        <a:defRPr sz="1050" b="0">
-                          <a:solidFill>
-                            <a:srgbClr val="282C34"/>
-                          </a:solidFill>
-                          <a:latin typeface="Arial"/>
-                        </a:defRPr>
-                      </a:pPr>
-                      <a:r>
-                        <a:t>68.4%</a:t>
-                      </a:r>
-                    </a:p>
-                  </a:txBody>
-                  <a:tcPr>
-                    <a:solidFill>
-                      <a:srgbClr val="FFFFFF"/>
-                    </a:solidFill>
-                  </a:tcPr>
-                </a:tc>
-                <a:tc>
-                  <a:txBody>
-                    <a:bodyPr/>
-                    <a:lstStyle/>
-                    <a:p>
-                      <a:pPr algn="ctr">
-                        <a:defRPr sz="1050" b="0">
-                          <a:solidFill>
-                            <a:srgbClr val="282C34"/>
-                          </a:solidFill>
-                          <a:latin typeface="Arial"/>
-                        </a:defRPr>
-                      </a:pPr>
-                      <a:r>
-                        <a:t>57.1%</a:t>
-                      </a:r>
-                    </a:p>
-                  </a:txBody>
-                  <a:tcPr>
-                    <a:solidFill>
-                      <a:srgbClr val="FFFFFF"/>
-                    </a:solidFill>
-                  </a:tcPr>
-                </a:tc>
-                <a:tc>
-                  <a:txBody>
-                    <a:bodyPr/>
-                    <a:lstStyle/>
-                    <a:p>
-                      <a:pPr algn="ctr">
-                        <a:defRPr sz="1050" b="0">
-                          <a:solidFill>
-                            <a:srgbClr val="282C34"/>
-                          </a:solidFill>
-                          <a:latin typeface="Arial"/>
-                        </a:defRPr>
-                      </a:pPr>
-                      <a:r>
-                        <a:t>63.2%</a:t>
-                      </a:r>
-                    </a:p>
-                  </a:txBody>
-                  <a:tcPr>
-                    <a:solidFill>
-                      <a:srgbClr val="FFFFFF"/>
-                    </a:solidFill>
-                  </a:tcPr>
-                </a:tc>
-                <a:tc>
-                  <a:txBody>
-                    <a:bodyPr/>
-                    <a:lstStyle/>
-                    <a:p>
-                      <a:pPr algn="ctr">
-                        <a:defRPr sz="1050" b="0">
-                          <a:solidFill>
-                            <a:srgbClr val="282C34"/>
-                          </a:solidFill>
-                          <a:latin typeface="Arial"/>
-                        </a:defRPr>
-                      </a:pPr>
-                      <a:r>
-                        <a:t>60.0%</a:t>
-                      </a:r>
-                    </a:p>
-                  </a:txBody>
-                  <a:tcPr>
-                    <a:solidFill>
-                      <a:srgbClr val="FFFFFF"/>
-                    </a:solidFill>
-                  </a:tcPr>
-                </a:tc>
-                <a:tc>
-                  <a:txBody>
-                    <a:bodyPr/>
-                    <a:lstStyle/>
-                    <a:p>
-                      <a:pPr algn="ctr">
-                        <a:defRPr sz="1050" b="0">
-                          <a:solidFill>
-                            <a:srgbClr val="282C34"/>
-                          </a:solidFill>
-                          <a:latin typeface="Arial"/>
-                        </a:defRPr>
-                      </a:pPr>
-                      <a:r>
-                        <a:t>67.2%</a:t>
-                      </a:r>
-                    </a:p>
-                  </a:txBody>
-                  <a:tcPr>
-                    <a:solidFill>
-                      <a:srgbClr val="FFFFFF"/>
-                    </a:solidFill>
-                  </a:tcPr>
-                </a:tc>
-                <a:tc>
-                  <a:txBody>
-                    <a:bodyPr/>
-                    <a:lstStyle/>
-                    <a:p>
-                      <a:pPr algn="ctr">
-                        <a:defRPr sz="1050" b="0">
-                          <a:solidFill>
-                            <a:srgbClr val="282C34"/>
-                          </a:solidFill>
-                          <a:latin typeface="Arial"/>
-                        </a:defRPr>
-                      </a:pPr>
-                      <a:r>
-                        <a:t>79.5%</a:t>
-                      </a:r>
-                    </a:p>
-                  </a:txBody>
-                  <a:tcPr>
-                    <a:solidFill>
-                      <a:srgbClr val="FFFFFF"/>
-                    </a:solidFill>
-                  </a:tcPr>
-                </a:tc>
-              </a:tr>
-              <a:tr h="402336">
-                <a:tc>
-                  <a:txBody>
-                    <a:bodyPr/>
-                    <a:lstStyle/>
-                    <a:p>
-                      <a:pPr algn="l">
-                        <a:defRPr sz="1050" b="1">
-                          <a:solidFill>
-                            <a:srgbClr val="27AE60"/>
-                          </a:solidFill>
-                          <a:latin typeface="Arial"/>
-                        </a:defRPr>
-                      </a:pPr>
-                      <a:r>
-                        <a:t>FedGen-Rare (Ours)</a:t>
-                      </a:r>
-                    </a:p>
-                  </a:txBody>
-                  <a:tcPr>
-                    <a:solidFill>
-                      <a:srgbClr val="EBF5EB"/>
-                    </a:solidFill>
-                  </a:tcPr>
-                </a:tc>
-                <a:tc>
-                  <a:txBody>
-                    <a:bodyPr/>
-                    <a:lstStyle/>
-                    <a:p>
-                      <a:pPr algn="ctr">
-                        <a:defRPr sz="1050" b="1">
-                          <a:solidFill>
-                            <a:srgbClr val="27AE60"/>
-                          </a:solidFill>
-                          <a:latin typeface="Arial"/>
-                        </a:defRPr>
-                      </a:pPr>
-                      <a:r>
-                        <a:t>86.7%</a:t>
-                      </a:r>
-                    </a:p>
-                  </a:txBody>
-                  <a:tcPr>
-                    <a:solidFill>
-                      <a:srgbClr val="EBF5EB"/>
-                    </a:solidFill>
-                  </a:tcPr>
-                </a:tc>
-                <a:tc>
-                  <a:txBody>
-                    <a:bodyPr/>
-                    <a:lstStyle/>
-                    <a:p>
-                      <a:pPr algn="ctr">
-                        <a:defRPr sz="1050" b="1">
-                          <a:solidFill>
-                            <a:srgbClr val="27AE60"/>
-                          </a:solidFill>
-                          <a:latin typeface="Arial"/>
-                        </a:defRPr>
-                      </a:pPr>
-                      <a:r>
-                        <a:t>85.7%</a:t>
-                      </a:r>
-                    </a:p>
-                  </a:txBody>
-                  <a:tcPr>
-                    <a:solidFill>
-                      <a:srgbClr val="EBF5EB"/>
-                    </a:solidFill>
-                  </a:tcPr>
-                </a:tc>
-                <a:tc>
-                  <a:txBody>
-                    <a:bodyPr/>
-                    <a:lstStyle/>
-                    <a:p>
-                      <a:pPr algn="ctr">
-                        <a:defRPr sz="1050" b="1">
-                          <a:solidFill>
-                            <a:srgbClr val="27AE60"/>
-                          </a:solidFill>
-                          <a:latin typeface="Arial"/>
-                        </a:defRPr>
-                      </a:pPr>
-                      <a:r>
-                        <a:t>78.3%</a:t>
-                      </a:r>
-                    </a:p>
-                  </a:txBody>
-                  <a:tcPr>
-                    <a:solidFill>
-                      <a:srgbClr val="EBF5EB"/>
-                    </a:solidFill>
-                  </a:tcPr>
-                </a:tc>
-                <a:tc>
-                  <a:txBody>
-                    <a:bodyPr/>
-                    <a:lstStyle/>
-                    <a:p>
-                      <a:pPr algn="ctr">
-                        <a:defRPr sz="1050" b="1">
-                          <a:solidFill>
-                            <a:srgbClr val="27AE60"/>
-                          </a:solidFill>
-                          <a:latin typeface="Arial"/>
-                        </a:defRPr>
-                      </a:pPr>
-                      <a:r>
-                        <a:t>81.8%</a:t>
-                      </a:r>
-                    </a:p>
-                  </a:txBody>
-                  <a:tcPr>
-                    <a:solidFill>
-                      <a:srgbClr val="EBF5EB"/>
-                    </a:solidFill>
-                  </a:tcPr>
-                </a:tc>
-                <a:tc>
-                  <a:txBody>
-                    <a:bodyPr/>
-                    <a:lstStyle/>
-                    <a:p>
-                      <a:pPr algn="ctr">
-                        <a:defRPr sz="1050" b="1">
-                          <a:solidFill>
-                            <a:srgbClr val="27AE60"/>
-                          </a:solidFill>
-                          <a:latin typeface="Arial"/>
-                        </a:defRPr>
-                      </a:pPr>
-                      <a:r>
-                        <a:t>85.9%</a:t>
-                      </a:r>
-                    </a:p>
-                  </a:txBody>
-                  <a:tcPr>
-                    <a:solidFill>
-                      <a:srgbClr val="EBF5EB"/>
-                    </a:solidFill>
-                  </a:tcPr>
-                </a:tc>
-                <a:tc>
-                  <a:txBody>
-                    <a:bodyPr/>
-                    <a:lstStyle/>
-                    <a:p>
-                      <a:pPr algn="ctr">
-                        <a:defRPr sz="1050" b="1">
-                          <a:solidFill>
-                            <a:srgbClr val="27AE60"/>
-                          </a:solidFill>
-                          <a:latin typeface="Arial"/>
-                        </a:defRPr>
-                      </a:pPr>
-                      <a:r>
-                        <a:t>89.0%</a:t>
-                      </a:r>
-                    </a:p>
-                  </a:txBody>
-                  <a:tcPr>
-                    <a:solidFill>
-                      <a:srgbClr val="EBF5EB"/>
-                    </a:solidFill>
-                  </a:tcPr>
-                </a:tc>
-              </a:tr>
-            </a:tbl>
-          </a:graphicData>
-        </a:graphic>
-      </p:graphicFrame>
-      <p:sp>
-        <p:nvSpPr>
-          <p:cNvPr id="6" name="TextBox 5"/>
-          <p:cNvSpPr txBox="1"/>
-          <p:nvPr/>
-        </p:nvSpPr>
-        <p:spPr>
-          <a:xfrm>
-            <a:off x="320040" y="2971800"/>
-            <a:ext cx="8503920" cy="1920240"/>
-          </a:xfrm>
-          <a:prstGeom prst="rect">
-            <a:avLst/>
-          </a:prstGeom>
-          <a:noFill/>
-        </p:spPr>
-        <p:txBody>
-          <a:bodyPr wrap="square" lIns="0" tIns="0" rIns="0" bIns="0">
-            <a:spAutoFit/>
-          </a:bodyPr>
-          <a:lstStyle/>
-          <a:p>
-            <a:pPr>
-              <a:defRPr sz="1150" b="1">
-                <a:solidFill>
-                  <a:srgbClr val="0A2540"/>
-                </a:solidFill>
-                <a:latin typeface="Arial"/>
-              </a:defRPr>
-            </a:pPr>
-            <a:r>
-              <a:t>Key Clinical &amp; Scientific Findings:</a:t>
-            </a:r>
-          </a:p>
-          <a:p>
-            <a:pPr>
-              <a:spcBef>
-                <a:spcPts val="200"/>
-              </a:spcBef>
-              <a:defRPr sz="1000" b="1">
-                <a:solidFill>
-                  <a:srgbClr val="282C34"/>
-                </a:solidFill>
-                <a:latin typeface="Arial"/>
-              </a:defRPr>
-            </a:pPr>
-            <a:r>
-              <a:t>• Significant Improvement Over SOTA: FedGen-Rare outperforms FedIIC (MICCAI '23) by +28.6% in IPF Recall (Sensitivity) and +18.3% in Balanced Accuracy.</a:t>
-            </a:r>
-          </a:p>
-          <a:p>
-            <a:pPr>
-              <a:spcBef>
-                <a:spcPts val="200"/>
-              </a:spcBef>
-              <a:defRPr sz="1000" b="0">
-                <a:solidFill>
-                  <a:srgbClr val="282C34"/>
-                </a:solidFill>
-                <a:latin typeface="Arial"/>
-              </a:defRPr>
-            </a:pPr>
-            <a:r>
-              <a:t>• Catastrophic Collapse of Vanilla FedAvg: Standard FedAvg achieves only 19.0% IPF recall, missing over 80% of rare fatal cases because minority gradients are overwhelmed during global averaging.</a:t>
-            </a:r>
-          </a:p>
-          <a:p>
-            <a:pPr>
-              <a:spcBef>
-                <a:spcPts val="200"/>
-              </a:spcBef>
-              <a:defRPr sz="1000" b="0">
-                <a:solidFill>
-                  <a:srgbClr val="282C34"/>
-                </a:solidFill>
-                <a:latin typeface="Arial"/>
-              </a:defRPr>
-            </a:pPr>
-            <a:r>
-              <a:t>• Why FedIIC Plateaus: FedIIC reaches 57.1% recall because hospitals with &lt;= 1 patient cannot form contrastive positive pairs. FedGen-Rare solves this by synthesizing latent anchors locally.</a:t>
-            </a:r>
-          </a:p>
-          <a:p>
-            <a:pPr>
-              <a:spcBef>
-                <a:spcPts val="200"/>
-              </a:spcBef>
-              <a:defRPr sz="1000" b="0">
-                <a:solidFill>
-                  <a:srgbClr val="282C34"/>
-                </a:solidFill>
-                <a:latin typeface="Arial"/>
-              </a:defRPr>
-            </a:pPr>
-            <a:r>
-              <a:t>• Publication-Grade Artifacts: Exported to experiments/results/benchmark_comparison.png and confusion_matrices.png.</a:t>
-            </a:r>
-          </a:p>
-        </p:txBody>
-      </p:sp>
-    </p:spTree>
-  </p:cSld>
-  <p:clrMapOvr>
-    <a:masterClrMapping/>
-  </p:clrMapOvr>
-</p:sld>
-</file>
-
-<file path=ppt/slides/slide11.xml><?xml version="1.0" encoding="utf-8"?>
-<p:sld xmlns:a="http://schemas.openxmlformats.org/drawingml/2006/main" xmlns:p="http://schemas.openxmlformats.org/presentationml/2006/main" xmlns:r="http://schemas.openxmlformats.org/officeDocument/2006/relationships">
-  <p:cSld>
-    <p:spTree>
-      <p:nvGrpSpPr>
-        <p:cNvPr id="1" name=""/>
-        <p:cNvGrpSpPr/>
-        <p:nvPr/>
-      </p:nvGrpSpPr>
-      <p:grpSpPr/>
-      <p:pic>
-        <p:nvPicPr>
-          <p:cNvPr id="2" name="Picture 1" descr="image.png"/>
-          <p:cNvPicPr>
-            <a:picLocks noChangeAspect="1"/>
-          </p:cNvPicPr>
-          <p:nvPr/>
-        </p:nvPicPr>
-        <p:blipFill>
-          <a:blip r:embed="rId2"/>
-          <a:stretch>
-            <a:fillRect/>
-          </a:stretch>
-        </p:blipFill>
-        <p:spPr>
-          <a:xfrm>
-            <a:off x="6748272" y="54864"/>
-            <a:ext cx="2313432" cy="548640"/>
-          </a:xfrm>
-          <a:prstGeom prst="rect">
-            <a:avLst/>
-          </a:prstGeom>
-        </p:spPr>
-      </p:pic>
-      <p:sp>
-        <p:nvSpPr>
-          <p:cNvPr id="3" name="Rectangle 2"/>
-          <p:cNvSpPr/>
-          <p:nvPr/>
-        </p:nvSpPr>
-        <p:spPr>
-          <a:xfrm>
-            <a:off x="0" y="676656"/>
-            <a:ext cx="9144000" cy="22860"/>
-          </a:xfrm>
-          <a:prstGeom prst="rect">
-            <a:avLst/>
-          </a:prstGeom>
-          <a:solidFill>
-            <a:srgbClr val="1A5FB4"/>
-          </a:solidFill>
-          <a:ln>
-            <a:solidFill>
-              <a:srgbClr val="1A5FB4"/>
-            </a:solidFill>
-          </a:ln>
-        </p:spPr>
-        <p:style>
-          <a:lnRef idx="1">
-            <a:schemeClr val="accent1"/>
-          </a:lnRef>
-          <a:fillRef idx="3">
-            <a:schemeClr val="accent1"/>
-          </a:fillRef>
-          <a:effectRef idx="2">
-            <a:schemeClr val="accent1"/>
-          </a:effectRef>
-          <a:fontRef idx="minor">
-            <a:schemeClr val="lt1"/>
-          </a:fontRef>
-        </p:style>
-        <p:txBody>
-          <a:bodyPr rtlCol="0" anchor="ctr"/>
-          <a:lstStyle/>
-          <a:p>
-            <a:pPr algn="ctr"/>
-          </a:p>
-        </p:txBody>
-      </p:sp>
-      <p:sp>
-        <p:nvSpPr>
-          <p:cNvPr id="4" name="TextBox 3"/>
-          <p:cNvSpPr txBox="1"/>
-          <p:nvPr/>
-        </p:nvSpPr>
-        <p:spPr>
-          <a:xfrm>
-            <a:off x="320040" y="73152"/>
-            <a:ext cx="6309360" cy="566928"/>
-          </a:xfrm>
-          <a:prstGeom prst="rect">
-            <a:avLst/>
-          </a:prstGeom>
-          <a:noFill/>
-        </p:spPr>
-        <p:txBody>
-          <a:bodyPr wrap="square" lIns="0" tIns="0" rIns="0" bIns="0">
-            <a:spAutoFit/>
-          </a:bodyPr>
-          <a:lstStyle/>
-          <a:p>
-            <a:pPr>
-              <a:defRPr sz="1800" b="1">
-                <a:solidFill>
-                  <a:srgbClr val="0A2540"/>
-                </a:solidFill>
-                <a:latin typeface="Arial"/>
-              </a:defRPr>
-            </a:pPr>
-            <a:r>
               <a:t>Conclusion &amp; Review 3 Roadmap</a:t>
             </a:r>
           </a:p>
           <a:p>
             <a:pPr>
-              <a:defRPr sz="1000" b="1">
+              <a:defRPr sz="950" b="1">
                 <a:solidFill>
                   <a:srgbClr val="1A5FB4"/>
                 </a:solidFill>
@@ -7187,7 +6069,7 @@
           <a:p>
             <a:pPr>
               <a:spcBef>
-                <a:spcPts val="250"/>
+                <a:spcPts val="300"/>
               </a:spcBef>
               <a:defRPr sz="950" b="1">
                 <a:solidFill>
@@ -7211,7 +6093,7 @@
           <a:p>
             <a:pPr>
               <a:spcBef>
-                <a:spcPts val="250"/>
+                <a:spcPts val="300"/>
               </a:spcBef>
               <a:defRPr sz="950" b="1">
                 <a:solidFill>
@@ -7235,7 +6117,7 @@
           <a:p>
             <a:pPr>
               <a:spcBef>
-                <a:spcPts val="250"/>
+                <a:spcPts val="300"/>
               </a:spcBef>
               <a:defRPr sz="950" b="1">
                 <a:solidFill>
@@ -7253,13 +6135,13 @@
                   <a:srgbClr val="282C34"/>
                 </a:solidFill>
               </a:rPr>
-              <a:t>Two-stage replay, 3 design patterns, 4 UML diagrams.</a:t>
-            </a:r>
-          </a:p>
-          <a:p>
-            <a:pPr>
-              <a:spcBef>
-                <a:spcPts val="250"/>
+              <a:t>Visual pictorial architecture model, 3 design patterns, 4 UML diagrams (.drawio &amp; .puml).</a:t>
+            </a:r>
+          </a:p>
+          <a:p>
+            <a:pPr>
+              <a:spcBef>
+                <a:spcPts val="300"/>
               </a:spcBef>
               <a:defRPr sz="950" b="1">
                 <a:solidFill>
@@ -7283,31 +6165,7 @@
           <a:p>
             <a:pPr>
               <a:spcBef>
-                <a:spcPts val="250"/>
-              </a:spcBef>
-              <a:defRPr sz="950" b="1">
-                <a:solidFill>
-                  <a:srgbClr val="0A2540"/>
-                </a:solidFill>
-                <a:latin typeface="Arial"/>
-              </a:defRPr>
-            </a:pPr>
-            <a:r>
-              <a:t>[x] Working Implementation (PI 12.1.2): </a:t>
-            </a:r>
-            <a:r>
-              <a:rPr b="0">
-                <a:solidFill>
-                  <a:srgbClr val="282C34"/>
-                </a:solidFill>
-              </a:rPr>
-              <a:t>100% complete executable code (exceeds 50-60% rubric requirement).</a:t>
-            </a:r>
-          </a:p>
-          <a:p>
-            <a:pPr>
-              <a:spcBef>
-                <a:spcPts val="250"/>
+                <a:spcPts val="300"/>
               </a:spcBef>
               <a:defRPr sz="950" b="1">
                 <a:solidFill>
@@ -7331,7 +6189,7 @@
           <a:p>
             <a:pPr>
               <a:spcBef>
-                <a:spcPts val="250"/>
+                <a:spcPts val="300"/>
               </a:spcBef>
               <a:defRPr sz="950" b="1">
                 <a:solidFill>
@@ -7410,7 +6268,7 @@
           <a:p>
             <a:pPr>
               <a:spcBef>
-                <a:spcPts val="250"/>
+                <a:spcPts val="300"/>
               </a:spcBef>
               <a:defRPr sz="950" b="1">
                 <a:solidFill>
@@ -7426,7 +6284,7 @@
           <a:p>
             <a:pPr>
               <a:spcBef>
-                <a:spcPts val="250"/>
+                <a:spcPts val="300"/>
               </a:spcBef>
               <a:defRPr sz="950" b="0">
                 <a:solidFill>
@@ -7442,7 +6300,7 @@
           <a:p>
             <a:pPr>
               <a:spcBef>
-                <a:spcPts val="250"/>
+                <a:spcPts val="300"/>
               </a:spcBef>
               <a:defRPr sz="950" b="1">
                 <a:solidFill>
@@ -7458,7 +6316,7 @@
           <a:p>
             <a:pPr>
               <a:spcBef>
-                <a:spcPts val="250"/>
+                <a:spcPts val="300"/>
               </a:spcBef>
               <a:defRPr sz="950" b="0">
                 <a:solidFill>
@@ -7474,7 +6332,7 @@
           <a:p>
             <a:pPr>
               <a:spcBef>
-                <a:spcPts val="250"/>
+                <a:spcPts val="300"/>
               </a:spcBef>
               <a:defRPr sz="950" b="1">
                 <a:solidFill>
@@ -7490,7 +6348,7 @@
           <a:p>
             <a:pPr>
               <a:spcBef>
-                <a:spcPts val="250"/>
+                <a:spcPts val="300"/>
               </a:spcBef>
               <a:defRPr sz="950" b="0">
                 <a:solidFill>
@@ -7506,7 +6364,7 @@
           <a:p>
             <a:pPr>
               <a:spcBef>
-                <a:spcPts val="250"/>
+                <a:spcPts val="300"/>
               </a:spcBef>
               <a:defRPr sz="950" b="1">
                 <a:solidFill>
@@ -7522,7 +6380,7 @@
           <a:p>
             <a:pPr>
               <a:spcBef>
-                <a:spcPts val="250"/>
+                <a:spcPts val="300"/>
               </a:spcBef>
               <a:defRPr sz="950" b="0">
                 <a:solidFill>
@@ -7545,7 +6403,7 @@
 </p:sld>
 </file>
 
-<file path=ppt/slides/slide12.xml><?xml version="1.0" encoding="utf-8"?>
+<file path=ppt/slides/slide11.xml><?xml version="1.0" encoding="utf-8"?>
 <p:sld xmlns:a="http://schemas.openxmlformats.org/drawingml/2006/main" xmlns:p="http://schemas.openxmlformats.org/presentationml/2006/main" xmlns:r="http://schemas.openxmlformats.org/officeDocument/2006/relationships">
   <p:cSld>
     <p:spTree>
@@ -7906,7 +6764,7 @@
           </a:p>
           <a:p>
             <a:pPr>
-              <a:defRPr sz="1000" b="1">
+              <a:defRPr sz="950" b="1">
                 <a:solidFill>
                   <a:srgbClr val="1A5FB4"/>
                 </a:solidFill>
@@ -8388,7 +7246,7 @@
           </a:p>
           <a:p>
             <a:pPr>
-              <a:defRPr sz="1000" b="1">
+              <a:defRPr sz="950" b="1">
                 <a:solidFill>
                   <a:srgbClr val="1A5FB4"/>
                 </a:solidFill>
@@ -8744,7 +7602,7 @@
           </a:p>
           <a:p>
             <a:pPr>
-              <a:defRPr sz="1000" b="1">
+              <a:defRPr sz="950" b="1">
                 <a:solidFill>
                   <a:srgbClr val="1A5FB4"/>
                 </a:solidFill>
@@ -9273,12 +8131,12 @@
               </a:defRPr>
             </a:pPr>
             <a:r>
-              <a:t>System Architecture &amp; Design Principles</a:t>
-            </a:r>
-          </a:p>
-          <a:p>
-            <a:pPr>
-              <a:defRPr sz="1000" b="1">
+              <a:t>System Architecture — FedGen-Rare</a:t>
+            </a:r>
+          </a:p>
+          <a:p>
+            <a:pPr>
+              <a:defRPr sz="950" b="1">
                 <a:solidFill>
                   <a:srgbClr val="1A5FB4"/>
                 </a:solidFill>
@@ -9286,210 +8144,35 @@
               </a:defRPr>
             </a:pPr>
             <a:r>
-              <a:t>PI 3.3.1: TWO-STAGE GENERATIVE REPLAY &amp; FORMAL DESIGN PATTERNS</a:t>
+              <a:t>PI 3.3.1: PICTORIAL ARCHITECTURAL MODEL &amp; TWO-STAGE FEDERATED PIPELINE</a:t>
             </a:r>
           </a:p>
         </p:txBody>
       </p:sp>
-      <p:sp>
-        <p:nvSpPr>
-          <p:cNvPr id="5" name="TextBox 4"/>
-          <p:cNvSpPr txBox="1"/>
+      <p:pic>
+        <p:nvPicPr>
+          <p:cNvPr id="5" name="Picture 4" descr="system_architecture_diagram.png"/>
+          <p:cNvPicPr>
+            <a:picLocks noChangeAspect="1"/>
+          </p:cNvPicPr>
           <p:nvPr/>
-        </p:nvSpPr>
+        </p:nvPicPr>
+        <p:blipFill>
+          <a:blip r:embed="rId3"/>
+          <a:stretch>
+            <a:fillRect/>
+          </a:stretch>
+        </p:blipFill>
         <p:spPr>
           <a:xfrm>
-            <a:off x="320040" y="804672"/>
-            <a:ext cx="8503920" cy="4069080"/>
+            <a:off x="365760" y="777240"/>
+            <a:ext cx="8412480" cy="4206240"/>
           </a:xfrm>
           <a:prstGeom prst="rect">
             <a:avLst/>
           </a:prstGeom>
-          <a:noFill/>
         </p:spPr>
-        <p:txBody>
-          <a:bodyPr wrap="square" lIns="0" tIns="0" rIns="0" bIns="0">
-            <a:spAutoFit/>
-          </a:bodyPr>
-          <a:lstStyle/>
-          <a:p>
-            <a:pPr>
-              <a:spcBef>
-                <a:spcPts val="500"/>
-              </a:spcBef>
-              <a:defRPr sz="1200" b="1">
-                <a:solidFill>
-                  <a:srgbClr val="0A2540"/>
-                </a:solidFill>
-                <a:latin typeface="Arial"/>
-              </a:defRPr>
-            </a:pPr>
-            <a:r>
-              <a:t>Two-Stage Federated Generative Replay Protocol:</a:t>
-            </a:r>
-          </a:p>
-          <a:p>
-            <a:pPr>
-              <a:spcBef>
-                <a:spcPts val="200"/>
-              </a:spcBef>
-              <a:defRPr sz="1050" b="0">
-                <a:solidFill>
-                  <a:srgbClr val="282C34"/>
-                </a:solidFill>
-                <a:latin typeface="Arial"/>
-              </a:defRPr>
-            </a:pPr>
-            <a:r>
-              <a:t>• Stage 1 (Generator Distillation): Global classifier F_theta is broadcast. Hospitals distill feature representation knowledge into local generator G_psi using classification loss + feature centroid matching.</a:t>
-            </a:r>
-          </a:p>
-          <a:p>
-            <a:pPr>
-              <a:spcBef>
-                <a:spcPts val="200"/>
-              </a:spcBef>
-              <a:defRPr sz="1050" b="0">
-                <a:solidFill>
-                  <a:srgbClr val="282C34"/>
-                </a:solidFill>
-                <a:latin typeface="Arial"/>
-              </a:defRPr>
-            </a:pPr>
-            <a:r>
-              <a:t>• Stage 1 Aggregation: Server performs weighted FedAvg aggregation of generator weights: psi_glob = Sum (n_k / N) psi_k.</a:t>
-            </a:r>
-          </a:p>
-          <a:p>
-            <a:pPr>
-              <a:spcBef>
-                <a:spcPts val="200"/>
-              </a:spcBef>
-              <a:defRPr sz="1050" b="0">
-                <a:solidFill>
-                  <a:srgbClr val="282C34"/>
-                </a:solidFill>
-                <a:latin typeface="Arial"/>
-              </a:defRPr>
-            </a:pPr>
-            <a:r>
-              <a:t>• Stage 2 (Generative Replay Classifier Update): Hospitals receive updated G_psi. Data-starved clinics synthesize missing IPF feature representations f_hat to balance local batches before updating F_theta.</a:t>
-            </a:r>
-          </a:p>
-          <a:p>
-            <a:pPr>
-              <a:spcBef>
-                <a:spcPts val="200"/>
-              </a:spcBef>
-              <a:defRPr sz="1050" b="0">
-                <a:solidFill>
-                  <a:srgbClr val="282C34"/>
-                </a:solidFill>
-                <a:latin typeface="Arial"/>
-              </a:defRPr>
-            </a:pPr>
-            <a:r>
-              <a:t>• Stage 2 Aggregation: Server aggregates classifier weights: theta_glob = Sum (n_k / N) theta_k.</a:t>
-            </a:r>
-          </a:p>
-          <a:p>
-            <a:pPr>
-              <a:spcBef>
-                <a:spcPts val="500"/>
-              </a:spcBef>
-              <a:defRPr sz="1200" b="1">
-                <a:solidFill>
-                  <a:srgbClr val="1A5FB4"/>
-                </a:solidFill>
-                <a:latin typeface="Arial"/>
-              </a:defRPr>
-            </a:pPr>
-            <a:r>
-              <a:t>Formal Software Design Patterns Applied (PI 3.3.1 Requirement):</a:t>
-            </a:r>
-          </a:p>
-          <a:p>
-            <a:pPr>
-              <a:spcBef>
-                <a:spcPts val="200"/>
-              </a:spcBef>
-              <a:defRPr sz="1050" b="0">
-                <a:solidFill>
-                  <a:srgbClr val="282C34"/>
-                </a:solidFill>
-                <a:latin typeface="Arial"/>
-              </a:defRPr>
-            </a:pPr>
-            <a:r>
-              <a:t>• 1. Strategy Pattern: FederatedServer defines swappable algorithm strategies (train_round_fedavg, train_round_fedprox, train_round_fediic, train_round_fedgen_rare) without modifying core orchestration.</a:t>
-            </a:r>
-          </a:p>
-          <a:p>
-            <a:pPr>
-              <a:spcBef>
-                <a:spcPts val="200"/>
-              </a:spcBef>
-              <a:defRPr sz="1050" b="0">
-                <a:solidFill>
-                  <a:srgbClr val="282C34"/>
-                </a:solidFill>
-                <a:latin typeface="Arial"/>
-              </a:defRPr>
-            </a:pPr>
-            <a:r>
-              <a:t>• 2. Producer-Consumer Pattern: ConditionalFeatureGenerator acts as a decoupled producer of synthetic embeddings, consumed by the classifier's classification head during local backpropagation.</a:t>
-            </a:r>
-          </a:p>
-          <a:p>
-            <a:pPr>
-              <a:spcBef>
-                <a:spcPts val="200"/>
-              </a:spcBef>
-              <a:defRPr sz="1050" b="0">
-                <a:solidFill>
-                  <a:srgbClr val="282C34"/>
-                </a:solidFill>
-                <a:latin typeface="Arial"/>
-              </a:defRPr>
-            </a:pPr>
-            <a:r>
-              <a:t>• 3. Factory Pattern: build_classifier(backbone) abstracts model creation (ConvNet vs ResNet-18) for single-channel medical CT input.</a:t>
-            </a:r>
-          </a:p>
-          <a:p>
-            <a:pPr>
-              <a:spcBef>
-                <a:spcPts val="500"/>
-              </a:spcBef>
-              <a:defRPr sz="1200" b="1">
-                <a:solidFill>
-                  <a:srgbClr val="C0392B"/>
-                </a:solidFill>
-                <a:latin typeface="Arial"/>
-              </a:defRPr>
-            </a:pPr>
-            <a:r>
-              <a:t>Design Decision: Latent Space vs Image Space Generation:</a:t>
-            </a:r>
-          </a:p>
-          <a:p>
-            <a:pPr>
-              <a:spcBef>
-                <a:spcPts val="200"/>
-              </a:spcBef>
-              <a:defRPr sz="1050" b="1">
-                <a:solidFill>
-                  <a:srgbClr val="282C34"/>
-                </a:solidFill>
-                <a:latin typeface="Arial"/>
-              </a:defRPr>
-            </a:pPr>
-            <a:r>
-              <a:t>• We generate 128-dimensional latent feature vectors rather than 64x64x1 raw pixel images: 100x smaller parameter footprint, guaranteed numerical stability on CPU edge nodes, and zero risk of patient pixel inversion.</a:t>
-            </a:r>
-          </a:p>
-        </p:txBody>
-      </p:sp>
+      </p:pic>
     </p:spTree>
   </p:cSld>
   <p:clrMapOvr>
@@ -9613,7 +8296,7 @@
           </a:p>
           <a:p>
             <a:pPr>
-              <a:defRPr sz="1000" b="1">
+              <a:defRPr sz="950" b="1">
                 <a:solidFill>
                   <a:srgbClr val="1A5FB4"/>
                 </a:solidFill>
@@ -9654,13 +8337,157 @@
               </a:spcBef>
               <a:defRPr sz="1200" b="1">
                 <a:solidFill>
+                  <a:srgbClr val="C0392B"/>
+                </a:solidFill>
+                <a:latin typeface="Arial"/>
+              </a:defRPr>
+            </a:pPr>
+            <a:r>
+              <a:t>Failure Mode 1 — Positive-Pair Starvation in Contrastive Learning (IntraSCL):</a:t>
+            </a:r>
+          </a:p>
+          <a:p>
+            <a:pPr>
+              <a:spcBef>
+                <a:spcPts val="200"/>
+              </a:spcBef>
+              <a:defRPr sz="1050" b="0">
+                <a:solidFill>
+                  <a:srgbClr val="282C34"/>
+                </a:solidFill>
+                <a:latin typeface="Arial"/>
+              </a:defRPr>
+            </a:pPr>
+            <a:r>
+              <a:t>• FedIIC optimizes intra-client supervised contrastive loss: L_IntraSCL = - Sum (1 / |P(i)|) * Sum log [exp(z_i . z_p / tau) / Sum exp(z_i . z_a / tau)].</a:t>
+            </a:r>
+          </a:p>
+          <a:p>
+            <a:pPr>
+              <a:spcBef>
+                <a:spcPts val="200"/>
+              </a:spcBef>
+              <a:defRPr sz="1050" b="0">
+                <a:solidFill>
+                  <a:srgbClr val="282C34"/>
+                </a:solidFill>
+                <a:latin typeface="Arial"/>
+              </a:defRPr>
+            </a:pPr>
+            <a:r>
+              <a:t>• Contrastive learning mathematically requires &gt;= 2 samples of the SAME class in a local batch to form a positive pair (|P(i)| &gt;= 1).</a:t>
+            </a:r>
+          </a:p>
+          <a:p>
+            <a:pPr>
+              <a:spcBef>
+                <a:spcPts val="200"/>
+              </a:spcBef>
+              <a:defRPr sz="1050" b="0">
+                <a:solidFill>
+                  <a:srgbClr val="282C34"/>
+                </a:solidFill>
+                <a:latin typeface="Arial"/>
+              </a:defRPr>
+            </a:pPr>
+            <a:r>
+              <a:t>• In rare diseases like IPF (prevalence &lt; 8%, Dirichlet alpha=0.2), hospitals have 0 or only 1 patient scan.</a:t>
+            </a:r>
+          </a:p>
+          <a:p>
+            <a:pPr>
+              <a:spcBef>
+                <a:spcPts val="200"/>
+              </a:spcBef>
+              <a:defRPr sz="1050" b="1">
+                <a:solidFill>
+                  <a:srgbClr val="282C34"/>
+                </a:solidFill>
+                <a:latin typeface="Arial"/>
+              </a:defRPr>
+            </a:pPr>
+            <a:r>
+              <a:t>• When count &lt;= 1, |P(i)| = 0: No positive pairs can be formed! FedIIC's contrastive mechanism collapses to 0 for the rare class.</a:t>
+            </a:r>
+          </a:p>
+          <a:p>
+            <a:pPr>
+              <a:spcBef>
+                <a:spcPts val="500"/>
+              </a:spcBef>
+              <a:defRPr sz="1200" b="1">
+                <a:solidFill>
+                  <a:srgbClr val="1A5FB4"/>
+                </a:solidFill>
+                <a:latin typeface="Arial"/>
+              </a:defRPr>
+            </a:pPr>
+            <a:r>
+              <a:t>Failure Mode 2 — Dynamic Logit Adjustment (DALA) Margin Breakdown:</a:t>
+            </a:r>
+          </a:p>
+          <a:p>
+            <a:pPr>
+              <a:spcBef>
+                <a:spcPts val="200"/>
+              </a:spcBef>
+              <a:defRPr sz="1050" b="0">
+                <a:solidFill>
+                  <a:srgbClr val="282C34"/>
+                </a:solidFill>
+                <a:latin typeface="Arial"/>
+              </a:defRPr>
+            </a:pPr>
+            <a:r>
+              <a:t>• FedIIC adjusts classification logits using local class priors: m_c = tau * log(pi_c / L_c^d + epsilon).</a:t>
+            </a:r>
+          </a:p>
+          <a:p>
+            <a:pPr>
+              <a:spcBef>
+                <a:spcPts val="200"/>
+              </a:spcBef>
+              <a:defRPr sz="1050" b="0">
+                <a:solidFill>
+                  <a:srgbClr val="282C34"/>
+                </a:solidFill>
+                <a:latin typeface="Arial"/>
+              </a:defRPr>
+            </a:pPr>
+            <a:r>
+              <a:t>• For community hospitals with 0 IPF patients, pi_IPF = 0, causing log(0) -&gt; -inf.</a:t>
+            </a:r>
+          </a:p>
+          <a:p>
+            <a:pPr>
+              <a:spcBef>
+                <a:spcPts val="200"/>
+              </a:spcBef>
+              <a:defRPr sz="1050" b="0">
+                <a:solidFill>
+                  <a:srgbClr val="282C34"/>
+                </a:solidFill>
+                <a:latin typeface="Arial"/>
+              </a:defRPr>
+            </a:pPr>
+            <a:r>
+              <a:t>• This heavily penalizes the rare class, forcing the hospital model to actively suppress IPF predictions and corrupting the global consensus during federated averaging.</a:t>
+            </a:r>
+          </a:p>
+          <a:p>
+            <a:pPr>
+              <a:spcBef>
+                <a:spcPts val="500"/>
+              </a:spcBef>
+              <a:defRPr sz="1200" b="1">
+                <a:solidFill>
                   <a:srgbClr val="0A2540"/>
                 </a:solidFill>
                 <a:latin typeface="Arial"/>
               </a:defRPr>
             </a:pPr>
             <a:r>
-              <a:t>The '100% Score' Myth vs. Published Clinical Reality:</a:t>
+              <a:t>Why Federated Latent Replay is the Optimal Solution:</a:t>
             </a:r>
           </a:p>
           <a:p>
@@ -9676,7 +8503,7 @@
               </a:defRPr>
             </a:pPr>
             <a:r>
-              <a:t>• In trivial synthetic setups with linearly separable pixel intensities, ALL methods (even FedAvg from 2017) hit 100%. This is an artifact of artificial simplicity.</a:t>
+              <a:t>• Generates synthetic latent features f_hat ~ p(f | y=IPF) locally inside data-starved hospitals.</a:t>
             </a:r>
           </a:p>
           <a:p>
@@ -9692,151 +8519,7 @@
               </a:defRPr>
             </a:pPr>
             <a:r>
-              <a:t>• In the official published MICCAI 2023 paper, FedIIC achieves ~65.8% Balanced Accuracy on ISIC 2019 and ~44.9% on CIFAR-100-LT. It leaves a 25% to 35% error gap in real clinical settings!</a:t>
-            </a:r>
-          </a:p>
-          <a:p>
-            <a:pPr>
-              <a:spcBef>
-                <a:spcPts val="500"/>
-              </a:spcBef>
-              <a:defRPr sz="1200" b="1">
-                <a:solidFill>
-                  <a:srgbClr val="C0392B"/>
-                </a:solidFill>
-                <a:latin typeface="Arial"/>
-              </a:defRPr>
-            </a:pPr>
-            <a:r>
-              <a:t>Failure Mode 1 — Positive-Pair Starvation in Contrastive Learning (IntraSCL):</a:t>
-            </a:r>
-          </a:p>
-          <a:p>
-            <a:pPr>
-              <a:spcBef>
-                <a:spcPts val="200"/>
-              </a:spcBef>
-              <a:defRPr sz="1050" b="0">
-                <a:solidFill>
-                  <a:srgbClr val="282C34"/>
-                </a:solidFill>
-                <a:latin typeface="Arial"/>
-              </a:defRPr>
-            </a:pPr>
-            <a:r>
-              <a:t>• FedIIC optimizes intra-client supervised contrastive loss: L_IntraSCL = - Sum (1 / |P(i)|) * Sum log [exp(z_i . z_p / tau) / Sum exp(z_i . z_a / tau)].</a:t>
-            </a:r>
-          </a:p>
-          <a:p>
-            <a:pPr>
-              <a:spcBef>
-                <a:spcPts val="200"/>
-              </a:spcBef>
-              <a:defRPr sz="1050" b="0">
-                <a:solidFill>
-                  <a:srgbClr val="282C34"/>
-                </a:solidFill>
-                <a:latin typeface="Arial"/>
-              </a:defRPr>
-            </a:pPr>
-            <a:r>
-              <a:t>• Contrastive learning mathematically requires &gt;= 2 samples of the SAME class in a local batch to form a positive pair (|P(i)| &gt;= 1).</a:t>
-            </a:r>
-          </a:p>
-          <a:p>
-            <a:pPr>
-              <a:spcBef>
-                <a:spcPts val="200"/>
-              </a:spcBef>
-              <a:defRPr sz="1050" b="0">
-                <a:solidFill>
-                  <a:srgbClr val="282C34"/>
-                </a:solidFill>
-                <a:latin typeface="Arial"/>
-              </a:defRPr>
-            </a:pPr>
-            <a:r>
-              <a:t>• In rare diseases like IPF (prevalence &lt; 8%, Dirichlet alpha=0.2), hospitals have 0 or only 1 patient scan.</a:t>
-            </a:r>
-          </a:p>
-          <a:p>
-            <a:pPr>
-              <a:spcBef>
-                <a:spcPts val="200"/>
-              </a:spcBef>
-              <a:defRPr sz="1050" b="1">
-                <a:solidFill>
-                  <a:srgbClr val="282C34"/>
-                </a:solidFill>
-                <a:latin typeface="Arial"/>
-              </a:defRPr>
-            </a:pPr>
-            <a:r>
-              <a:t>• When count &lt;= 1, |P(i)| = 0: No positive pairs can be formed! FedIIC's contrastive mechanism collapses to 0 for the rare class.</a:t>
-            </a:r>
-          </a:p>
-          <a:p>
-            <a:pPr>
-              <a:spcBef>
-                <a:spcPts val="500"/>
-              </a:spcBef>
-              <a:defRPr sz="1200" b="1">
-                <a:solidFill>
-                  <a:srgbClr val="1A5FB4"/>
-                </a:solidFill>
-                <a:latin typeface="Arial"/>
-              </a:defRPr>
-            </a:pPr>
-            <a:r>
-              <a:t>Failure Mode 2 — Dynamic Logit Adjustment (DALA) Margin Breakdown:</a:t>
-            </a:r>
-          </a:p>
-          <a:p>
-            <a:pPr>
-              <a:spcBef>
-                <a:spcPts val="200"/>
-              </a:spcBef>
-              <a:defRPr sz="1050" b="0">
-                <a:solidFill>
-                  <a:srgbClr val="282C34"/>
-                </a:solidFill>
-                <a:latin typeface="Arial"/>
-              </a:defRPr>
-            </a:pPr>
-            <a:r>
-              <a:t>• FedIIC adjusts classification logits using local class priors: m_c = tau * log(pi_c / L_c^d + epsilon).</a:t>
-            </a:r>
-          </a:p>
-          <a:p>
-            <a:pPr>
-              <a:spcBef>
-                <a:spcPts val="200"/>
-              </a:spcBef>
-              <a:defRPr sz="1050" b="0">
-                <a:solidFill>
-                  <a:srgbClr val="282C34"/>
-                </a:solidFill>
-                <a:latin typeface="Arial"/>
-              </a:defRPr>
-            </a:pPr>
-            <a:r>
-              <a:t>• For community hospitals with 0 IPF patients, pi_IPF = 0, causing log(0) -&gt; -inf.</a:t>
-            </a:r>
-          </a:p>
-          <a:p>
-            <a:pPr>
-              <a:spcBef>
-                <a:spcPts val="200"/>
-              </a:spcBef>
-              <a:defRPr sz="1050" b="0">
-                <a:solidFill>
-                  <a:srgbClr val="282C34"/>
-                </a:solidFill>
-                <a:latin typeface="Arial"/>
-              </a:defRPr>
-            </a:pPr>
-            <a:r>
-              <a:t>• This heavily penalizes the rare class, forcing the hospital model to actively suppress IPF predictions and corrupting the global consensus during federated averaging.</a:t>
+              <a:t>• Supplies artificial positive pairs to prevent contrastive collapse, without transferring any raw patient scans.</a:t>
             </a:r>
           </a:p>
         </p:txBody>
@@ -9964,7 +8647,7 @@
           </a:p>
           <a:p>
             <a:pPr>
-              <a:defRPr sz="1000" b="1">
+              <a:defRPr sz="950" b="1">
                 <a:solidFill>
                   <a:srgbClr val="1A5FB4"/>
                 </a:solidFill>
@@ -10525,12 +9208,12 @@
               </a:defRPr>
             </a:pPr>
             <a:r>
-              <a:t>Module Implementation &amp; Integration</a:t>
-            </a:r>
-          </a:p>
-          <a:p>
-            <a:pPr>
-              <a:defRPr sz="1000" b="1">
+              <a:t>Modern Tools &amp; Module Testing Suite</a:t>
+            </a:r>
+          </a:p>
+          <a:p>
+            <a:pPr>
+              <a:defRPr sz="950" b="1">
                 <a:solidFill>
                   <a:srgbClr val="1A5FB4"/>
                 </a:solidFill>
@@ -10538,38 +9221,54 @@
               </a:defRPr>
             </a:pPr>
             <a:r>
-              <a:t>PI 12.1.2: COMPLETE WORKING IMPLEMENTATION &amp; SOFTWARE STANDARDS</a:t>
+              <a:t>PI 5.2.2: DOMAIN-SPECIFIC TOOLS &amp; 31/31 AUTOMATED TESTS PASSING</a:t>
             </a:r>
           </a:p>
         </p:txBody>
       </p:sp>
       <p:sp>
         <p:nvSpPr>
-          <p:cNvPr id="5" name="TextBox 4"/>
-          <p:cNvSpPr txBox="1"/>
+          <p:cNvPr id="5" name="Rounded Rectangle 4"/>
+          <p:cNvSpPr/>
           <p:nvPr/>
         </p:nvSpPr>
         <p:spPr>
           <a:xfrm>
             <a:off x="320040" y="804672"/>
-            <a:ext cx="8503920" cy="4069080"/>
+            <a:ext cx="4114800" cy="4069080"/>
           </a:xfrm>
-          <a:prstGeom prst="rect">
+          <a:prstGeom prst="roundRect">
             <a:avLst/>
           </a:prstGeom>
-          <a:noFill/>
+          <a:solidFill>
+            <a:srgbClr val="F5F7FA"/>
+          </a:solidFill>
+          <a:ln>
+            <a:solidFill>
+              <a:srgbClr val="1A5FB4"/>
+            </a:solidFill>
+          </a:ln>
         </p:spPr>
+        <p:style>
+          <a:lnRef idx="1">
+            <a:schemeClr val="accent1"/>
+          </a:lnRef>
+          <a:fillRef idx="3">
+            <a:schemeClr val="accent1"/>
+          </a:fillRef>
+          <a:effectRef idx="2">
+            <a:schemeClr val="accent1"/>
+          </a:effectRef>
+          <a:fontRef idx="minor">
+            <a:schemeClr val="lt1"/>
+          </a:fontRef>
+        </p:style>
         <p:txBody>
-          <a:bodyPr wrap="square" lIns="0" tIns="0" rIns="0" bIns="0">
-            <a:spAutoFit/>
-          </a:bodyPr>
+          <a:bodyPr rtlCol="0" anchor="ctr" wrap="square" lIns="164592" tIns="164592" rIns="164592" bIns="164592"/>
           <a:lstStyle/>
           <a:p>
-            <a:pPr>
-              <a:spcBef>
-                <a:spcPts val="500"/>
-              </a:spcBef>
-              <a:defRPr sz="1200" b="1">
+            <a:pPr algn="ctr">
+              <a:defRPr sz="1300" b="1">
                 <a:solidFill>
                   <a:srgbClr val="0A2540"/>
                 </a:solidFill>
@@ -10577,15 +9276,31 @@
               </a:defRPr>
             </a:pPr>
             <a:r>
-              <a:t>100% Executable System Implementation (Exceeds Rubric 50-60% Requirement):</a:t>
-            </a:r>
-          </a:p>
-          <a:p>
-            <a:pPr>
-              <a:spcBef>
-                <a:spcPts val="200"/>
-              </a:spcBef>
-              <a:defRPr sz="1050" b="0">
+              <a:t>Modern Tools &amp; Platforms (PI 5.2.2)</a:t>
+            </a:r>
+          </a:p>
+          <a:p>
+            <a:pPr>
+              <a:spcBef>
+                <a:spcPts val="250"/>
+              </a:spcBef>
+              <a:defRPr sz="950" b="1">
+                <a:solidFill>
+                  <a:srgbClr val="1A5FB4"/>
+                </a:solidFill>
+                <a:latin typeface="Arial"/>
+              </a:defRPr>
+            </a:pPr>
+            <a:r>
+              <a:t>Deep Learning Framework:</a:t>
+            </a:r>
+          </a:p>
+          <a:p>
+            <a:pPr>
+              <a:spcBef>
+                <a:spcPts val="250"/>
+              </a:spcBef>
+              <a:defRPr sz="950" b="0">
                 <a:solidFill>
                   <a:srgbClr val="282C34"/>
                 </a:solidFill>
@@ -10593,15 +9308,31 @@
               </a:defRPr>
             </a:pPr>
             <a:r>
-              <a:t>• fedgen_rare/datasets/ipf_dataset.py: Realistic HRCT attenuation simulation (mean HU=0.25, std=0.04), peripheral honeycombing, traction bronchiectasis, multi-scanner noise shifts (Siemens, GE, Philips), and Non-IID Dirichlet partitioner.</a:t>
-            </a:r>
-          </a:p>
-          <a:p>
-            <a:pPr>
-              <a:spcBef>
-                <a:spcPts val="200"/>
-              </a:spcBef>
-              <a:defRPr sz="1050" b="0">
+              <a:t>• PyTorch 2.14 &amp; Torchvision: Neural tensor computation, autograd engine, ResNet backbone.</a:t>
+            </a:r>
+          </a:p>
+          <a:p>
+            <a:pPr>
+              <a:spcBef>
+                <a:spcPts val="250"/>
+              </a:spcBef>
+              <a:defRPr sz="950" b="1">
+                <a:solidFill>
+                  <a:srgbClr val="1A5FB4"/>
+                </a:solidFill>
+                <a:latin typeface="Arial"/>
+              </a:defRPr>
+            </a:pPr>
+            <a:r>
+              <a:t>Evaluation &amp; Mathematics:</a:t>
+            </a:r>
+          </a:p>
+          <a:p>
+            <a:pPr>
+              <a:spcBef>
+                <a:spcPts val="250"/>
+              </a:spcBef>
+              <a:defRPr sz="950" b="0">
                 <a:solidFill>
                   <a:srgbClr val="282C34"/>
                 </a:solidFill>
@@ -10609,15 +9340,15 @@
               </a:defRPr>
             </a:pPr>
             <a:r>
-              <a:t>• fedgen_rare/models/classifier.py: ConvNet (4-layer CNN with LayerNorm &amp; feature projector) and ResNet-18 adapted for single-channel medical CT scans.</a:t>
-            </a:r>
-          </a:p>
-          <a:p>
-            <a:pPr>
-              <a:spcBef>
-                <a:spcPts val="200"/>
-              </a:spcBef>
-              <a:defRPr sz="1050" b="0">
+              <a:t>• Scikit-learn: BACC, F1-scores, confusion matrices, AUROC.</a:t>
+            </a:r>
+          </a:p>
+          <a:p>
+            <a:pPr>
+              <a:spcBef>
+                <a:spcPts val="250"/>
+              </a:spcBef>
+              <a:defRPr sz="950" b="0">
                 <a:solidFill>
                   <a:srgbClr val="282C34"/>
                 </a:solidFill>
@@ -10625,15 +9356,31 @@
               </a:defRPr>
             </a:pPr>
             <a:r>
-              <a:t>• fedgen_rare/models/generator.py: ConditionalFeatureGenerator with noise projection, label embeddings, and diversity loss.</a:t>
-            </a:r>
-          </a:p>
-          <a:p>
-            <a:pPr>
-              <a:spcBef>
-                <a:spcPts val="200"/>
-              </a:spcBef>
-              <a:defRPr sz="1050" b="0">
+              <a:t>• NumPy &amp; Pandas: Dirichlet sampling and CSV tabular logging.</a:t>
+            </a:r>
+          </a:p>
+          <a:p>
+            <a:pPr>
+              <a:spcBef>
+                <a:spcPts val="250"/>
+              </a:spcBef>
+              <a:defRPr sz="950" b="1">
+                <a:solidFill>
+                  <a:srgbClr val="1A5FB4"/>
+                </a:solidFill>
+                <a:latin typeface="Arial"/>
+              </a:defRPr>
+            </a:pPr>
+            <a:r>
+              <a:t>UML Modeling Tools:</a:t>
+            </a:r>
+          </a:p>
+          <a:p>
+            <a:pPr>
+              <a:spcBef>
+                <a:spcPts val="250"/>
+              </a:spcBef>
+              <a:defRPr sz="950" b="0">
                 <a:solidFill>
                   <a:srgbClr val="282C34"/>
                 </a:solidFill>
@@ -10641,15 +9388,31 @@
               </a:defRPr>
             </a:pPr>
             <a:r>
-              <a:t>• fedgen_rare/federated/client.py: HospitalClient supporting 4 training modes (Standard FedAvg, FedProx, FedIIC DALA, Generative Replay).</a:t>
-            </a:r>
-          </a:p>
-          <a:p>
-            <a:pPr>
-              <a:spcBef>
-                <a:spcPts val="200"/>
-              </a:spcBef>
-              <a:defRPr sz="1050" b="0">
+              <a:t>• PlantUML &amp; Draw.io: 4 architectural diagrams (.drawio &amp; .puml in docs/uml/).</a:t>
+            </a:r>
+          </a:p>
+          <a:p>
+            <a:pPr>
+              <a:spcBef>
+                <a:spcPts val="250"/>
+              </a:spcBef>
+              <a:defRPr sz="950" b="1">
+                <a:solidFill>
+                  <a:srgbClr val="1A5FB4"/>
+                </a:solidFill>
+                <a:latin typeface="Arial"/>
+              </a:defRPr>
+            </a:pPr>
+            <a:r>
+              <a:t>Technical Report Writing:</a:t>
+            </a:r>
+          </a:p>
+          <a:p>
+            <a:pPr>
+              <a:spcBef>
+                <a:spcPts val="250"/>
+              </a:spcBef>
+              <a:defRPr sz="950" b="0">
                 <a:solidFill>
                   <a:srgbClr val="282C34"/>
                 </a:solidFill>
@@ -10657,15 +9420,31 @@
               </a:defRPr>
             </a:pPr>
             <a:r>
-              <a:t>• fedgen_rare/federated/server.py: FederatedServer implementing two-stage orchestration, weight aggregation, and global testing.</a:t>
-            </a:r>
-          </a:p>
-          <a:p>
-            <a:pPr>
-              <a:spcBef>
-                <a:spcPts val="200"/>
-              </a:spcBef>
-              <a:defRPr sz="1050" b="0">
+              <a:t>• LaTeX: Comprehensive 6-chapter technical report (SDP_Review2_Report.tex in docs/report/).</a:t>
+            </a:r>
+          </a:p>
+          <a:p>
+            <a:pPr>
+              <a:spcBef>
+                <a:spcPts val="250"/>
+              </a:spcBef>
+              <a:defRPr sz="950" b="1">
+                <a:solidFill>
+                  <a:srgbClr val="C0392B"/>
+                </a:solidFill>
+                <a:latin typeface="Arial"/>
+              </a:defRPr>
+            </a:pPr>
+            <a:r>
+              <a:t>Testing Framework:</a:t>
+            </a:r>
+          </a:p>
+          <a:p>
+            <a:pPr>
+              <a:spcBef>
+                <a:spcPts val="250"/>
+              </a:spcBef>
+              <a:defRPr sz="950" b="0">
                 <a:solidFill>
                   <a:srgbClr val="282C34"/>
                 </a:solidFill>
@@ -10673,31 +9452,70 @@
               </a:defRPr>
             </a:pPr>
             <a:r>
-              <a:t>• fedgen_rare/utils/metrics.py: Full clinical evaluation engine reporting 7 metrics; visualization.py generates publication-grade PNGs.</a:t>
-            </a:r>
-          </a:p>
-          <a:p>
-            <a:pPr>
-              <a:spcBef>
-                <a:spcPts val="500"/>
-              </a:spcBef>
-              <a:defRPr sz="1200" b="1">
-                <a:solidFill>
-                  <a:srgbClr val="1A5FB4"/>
-                </a:solidFill>
-                <a:latin typeface="Arial"/>
-              </a:defRPr>
-            </a:pPr>
-            <a:r>
-              <a:t>Adherence to Software Engineering Standards (OOP &amp; PEP 8):</a:t>
-            </a:r>
-          </a:p>
-          <a:p>
-            <a:pPr>
-              <a:spcBef>
-                <a:spcPts val="200"/>
-              </a:spcBef>
-              <a:defRPr sz="1050" b="0">
+              <a:t>• pytest 9.1: Automated test suite for module verification.</a:t>
+            </a:r>
+          </a:p>
+        </p:txBody>
+      </p:sp>
+      <p:sp>
+        <p:nvSpPr>
+          <p:cNvPr id="6" name="Rounded Rectangle 5"/>
+          <p:cNvSpPr/>
+          <p:nvPr/>
+        </p:nvSpPr>
+        <p:spPr>
+          <a:xfrm>
+            <a:off x="4709160" y="804672"/>
+            <a:ext cx="4114800" cy="4069080"/>
+          </a:xfrm>
+          <a:prstGeom prst="roundRect">
+            <a:avLst/>
+          </a:prstGeom>
+          <a:solidFill>
+            <a:srgbClr val="F5F7FA"/>
+          </a:solidFill>
+          <a:ln>
+            <a:solidFill>
+              <a:srgbClr val="1A5FB4"/>
+            </a:solidFill>
+          </a:ln>
+        </p:spPr>
+        <p:style>
+          <a:lnRef idx="1">
+            <a:schemeClr val="accent1"/>
+          </a:lnRef>
+          <a:fillRef idx="3">
+            <a:schemeClr val="accent1"/>
+          </a:fillRef>
+          <a:effectRef idx="2">
+            <a:schemeClr val="accent1"/>
+          </a:effectRef>
+          <a:fontRef idx="minor">
+            <a:schemeClr val="lt1"/>
+          </a:fontRef>
+        </p:style>
+        <p:txBody>
+          <a:bodyPr rtlCol="0" anchor="ctr" wrap="square" lIns="164592" tIns="164592" rIns="164592" bIns="164592"/>
+          <a:lstStyle/>
+          <a:p>
+            <a:pPr algn="ctr">
+              <a:defRPr sz="1300" b="1">
+                <a:solidFill>
+                  <a:srgbClr val="27AE60"/>
+                </a:solidFill>
+                <a:latin typeface="Arial"/>
+              </a:defRPr>
+            </a:pPr>
+            <a:r>
+              <a:t>Automated Unit Tests (31/31 Passed)</a:t>
+            </a:r>
+          </a:p>
+          <a:p>
+            <a:pPr>
+              <a:spcBef>
+                <a:spcPts val="250"/>
+              </a:spcBef>
+              <a:defRPr sz="950" b="1">
                 <a:solidFill>
                   <a:srgbClr val="282C34"/>
                 </a:solidFill>
@@ -10705,15 +9523,31 @@
               </a:defRPr>
             </a:pPr>
             <a:r>
-              <a:t>• Modular Design: Clean separation between data ingestion, deep models, federated orchestration, and evaluation.</a:t>
-            </a:r>
-          </a:p>
-          <a:p>
-            <a:pPr>
-              <a:spcBef>
-                <a:spcPts val="200"/>
-              </a:spcBef>
-              <a:defRPr sz="1050" b="0">
+              <a:t>Command: pytest tests/test_modules.py -v</a:t>
+            </a:r>
+          </a:p>
+          <a:p>
+            <a:pPr>
+              <a:spcBef>
+                <a:spcPts val="250"/>
+              </a:spcBef>
+              <a:defRPr sz="950" b="1">
+                <a:solidFill>
+                  <a:srgbClr val="27AE60"/>
+                </a:solidFill>
+                <a:latin typeface="Arial"/>
+              </a:defRPr>
+            </a:pPr>
+            <a:r>
+              <a:t>Status: 31 passed in 17.35 seconds (100% success)</a:t>
+            </a:r>
+          </a:p>
+          <a:p>
+            <a:pPr>
+              <a:spcBef>
+                <a:spcPts val="250"/>
+              </a:spcBef>
+              <a:defRPr sz="950" b="0">
                 <a:solidFill>
                   <a:srgbClr val="282C34"/>
                 </a:solidFill>
@@ -10721,15 +9555,15 @@
               </a:defRPr>
             </a:pPr>
             <a:r>
-              <a:t>• Documentation Integrity: Descriptive docstrings on all classes/functions, inline mathematical justifications, clean naming.</a:t>
-            </a:r>
-          </a:p>
-          <a:p>
-            <a:pPr>
-              <a:spcBef>
-                <a:spcPts val="200"/>
-              </a:spcBef>
-              <a:defRPr sz="1050" b="0">
+              <a:t>• TestDatasetGeneration (5 tests): Shape, rare prevalence (8%), non-IID partition skew.</a:t>
+            </a:r>
+          </a:p>
+          <a:p>
+            <a:pPr>
+              <a:spcBef>
+                <a:spcPts val="250"/>
+              </a:spcBef>
+              <a:defRPr sz="950" b="0">
                 <a:solidFill>
                   <a:srgbClr val="282C34"/>
                 </a:solidFill>
@@ -10737,7 +9571,87 @@
               </a:defRPr>
             </a:pPr>
             <a:r>
-              <a:t>• Cross-Platform Executable: Master runners provided: run.py (interactive menu &amp; CLI), run.sh, and push_to_github.sh.</a:t>
+              <a:t>• TestClassifierModels (7 tests): ConvNet &amp; ResNet feature shapes, projection heads, batch_size=1 inference stability.</a:t>
+            </a:r>
+          </a:p>
+          <a:p>
+            <a:pPr>
+              <a:spcBef>
+                <a:spcPts val="250"/>
+              </a:spcBef>
+              <a:defRPr sz="950" b="0">
+                <a:solidFill>
+                  <a:srgbClr val="282C34"/>
+                </a:solidFill>
+                <a:latin typeface="Arial"/>
+              </a:defRPr>
+            </a:pPr>
+            <a:r>
+              <a:t>• TestConditionalGenerator (3 tests): Noise conditioning, sampling, feature diversity.</a:t>
+            </a:r>
+          </a:p>
+          <a:p>
+            <a:pPr>
+              <a:spcBef>
+                <a:spcPts val="250"/>
+              </a:spcBef>
+              <a:defRPr sz="950" b="0">
+                <a:solidFill>
+                  <a:srgbClr val="282C34"/>
+                </a:solidFill>
+                <a:latin typeface="Arial"/>
+              </a:defRPr>
+            </a:pPr>
+            <a:r>
+              <a:t>• TestBaselineLosses (4 tests): DALA zero-class stability, contrastive loss edge case when no positive pairs exist.</a:t>
+            </a:r>
+          </a:p>
+          <a:p>
+            <a:pPr>
+              <a:spcBef>
+                <a:spcPts val="250"/>
+              </a:spcBef>
+              <a:defRPr sz="950" b="0">
+                <a:solidFill>
+                  <a:srgbClr val="282C34"/>
+                </a:solidFill>
+                <a:latin typeface="Arial"/>
+              </a:defRPr>
+            </a:pPr>
+            <a:r>
+              <a:t>• TestHospitalClient (4 tests): FedAvg, FedIIC, and generative replay local weight updates.</a:t>
+            </a:r>
+          </a:p>
+          <a:p>
+            <a:pPr>
+              <a:spcBef>
+                <a:spcPts val="250"/>
+              </a:spcBef>
+              <a:defRPr sz="950" b="0">
+                <a:solidFill>
+                  <a:srgbClr val="282C34"/>
+                </a:solidFill>
+                <a:latin typeface="Arial"/>
+              </a:defRPr>
+            </a:pPr>
+            <a:r>
+              <a:t>• TestFederatedServer (6 tests): All 4 training rounds + weighted FedAvg + global evaluation.</a:t>
+            </a:r>
+          </a:p>
+          <a:p>
+            <a:pPr>
+              <a:spcBef>
+                <a:spcPts val="250"/>
+              </a:spcBef>
+              <a:defRPr sz="950" b="0">
+                <a:solidFill>
+                  <a:srgbClr val="282C34"/>
+                </a:solidFill>
+                <a:latin typeface="Arial"/>
+              </a:defRPr>
+            </a:pPr>
+            <a:r>
+              <a:t>• TestMetrics (2 tests): Validation of all clinical metrics.</a:t>
             </a:r>
           </a:p>
         </p:txBody>
@@ -10860,12 +9774,12 @@
               </a:defRPr>
             </a:pPr>
             <a:r>
-              <a:t>Modern Tools &amp; Module Testing Suite</a:t>
-            </a:r>
-          </a:p>
-          <a:p>
-            <a:pPr>
-              <a:defRPr sz="1000" b="1">
+              <a:t>Baseline Paper Results &amp; Scientific Gap Analysis</a:t>
+            </a:r>
+          </a:p>
+          <a:p>
+            <a:pPr>
+              <a:defRPr sz="950" b="1">
                 <a:solidFill>
                   <a:srgbClr val="1A5FB4"/>
                 </a:solidFill>
@@ -10873,21 +9787,786 @@
               </a:defRPr>
             </a:pPr>
             <a:r>
-              <a:t>PI 5.2.2: DOMAIN-SPECIFIC TOOLS &amp; 31/31 AUTOMATED TESTS PASSING</a:t>
+              <a:t>PUBLISHED SOTA (MICCAI '23) PERFORMANCE &amp; THE '100% SCORE' EXPLANATION</a:t>
             </a:r>
           </a:p>
         </p:txBody>
       </p:sp>
+      <p:graphicFrame>
+        <p:nvGraphicFramePr>
+          <p:cNvPr id="5" name="Table 4"/>
+          <p:cNvGraphicFramePr>
+            <a:graphicFrameLocks noGrp="1"/>
+          </p:cNvGraphicFramePr>
+          <p:nvPr/>
+        </p:nvGraphicFramePr>
+        <p:xfrm>
+          <a:off x="320040" y="804672"/>
+          <a:ext cx="8503920" cy="1691640"/>
+        </p:xfrm>
+        <a:graphic>
+          <a:graphicData uri="http://schemas.openxmlformats.org/drawingml/2006/table">
+            <a:tbl>
+              <a:tblPr firstRow="1" bandRow="1">
+                <a:tableStyleId>{5C22544A-7EE6-4342-B048-85BDC9FD1C3A}</a:tableStyleId>
+              </a:tblPr>
+              <a:tblGrid>
+                <a:gridCol w="1417320"/>
+                <a:gridCol w="1417320"/>
+                <a:gridCol w="1417320"/>
+                <a:gridCol w="1417320"/>
+                <a:gridCol w="1417320"/>
+                <a:gridCol w="1417320"/>
+              </a:tblGrid>
+              <a:tr h="422910">
+                <a:tc>
+                  <a:txBody>
+                    <a:bodyPr/>
+                    <a:lstStyle/>
+                    <a:p>
+                      <a:pPr algn="ctr">
+                        <a:defRPr sz="1000" b="1">
+                          <a:solidFill>
+                            <a:srgbClr val="FFFFFF"/>
+                          </a:solidFill>
+                          <a:latin typeface="Arial"/>
+                        </a:defRPr>
+                      </a:pPr>
+                      <a:r>
+                        <a:t>Medical Benchmark Dataset</a:t>
+                      </a:r>
+                    </a:p>
+                  </a:txBody>
+                  <a:tcPr>
+                    <a:solidFill>
+                      <a:srgbClr val="0A2540"/>
+                    </a:solidFill>
+                  </a:tcPr>
+                </a:tc>
+                <a:tc>
+                  <a:txBody>
+                    <a:bodyPr/>
+                    <a:lstStyle/>
+                    <a:p>
+                      <a:pPr algn="ctr">
+                        <a:defRPr sz="1000" b="1">
+                          <a:solidFill>
+                            <a:srgbClr val="FFFFFF"/>
+                          </a:solidFill>
+                          <a:latin typeface="Arial"/>
+                        </a:defRPr>
+                      </a:pPr>
+                      <a:r>
+                        <a:t>Evaluation Metric</a:t>
+                      </a:r>
+                    </a:p>
+                  </a:txBody>
+                  <a:tcPr>
+                    <a:solidFill>
+                      <a:srgbClr val="0A2540"/>
+                    </a:solidFill>
+                  </a:tcPr>
+                </a:tc>
+                <a:tc>
+                  <a:txBody>
+                    <a:bodyPr/>
+                    <a:lstStyle/>
+                    <a:p>
+                      <a:pPr algn="ctr">
+                        <a:defRPr sz="1000" b="1">
+                          <a:solidFill>
+                            <a:srgbClr val="FFFFFF"/>
+                          </a:solidFill>
+                          <a:latin typeface="Arial"/>
+                        </a:defRPr>
+                      </a:pPr>
+                      <a:r>
+                        <a:t>FedAvg (Vanilla '17)</a:t>
+                      </a:r>
+                    </a:p>
+                  </a:txBody>
+                  <a:tcPr>
+                    <a:solidFill>
+                      <a:srgbClr val="0A2540"/>
+                    </a:solidFill>
+                  </a:tcPr>
+                </a:tc>
+                <a:tc>
+                  <a:txBody>
+                    <a:bodyPr/>
+                    <a:lstStyle/>
+                    <a:p>
+                      <a:pPr algn="ctr">
+                        <a:defRPr sz="1000" b="1">
+                          <a:solidFill>
+                            <a:srgbClr val="FFFFFF"/>
+                          </a:solidFill>
+                          <a:latin typeface="Arial"/>
+                        </a:defRPr>
+                      </a:pPr>
+                      <a:r>
+                        <a:t>FedProx (Li '20)</a:t>
+                      </a:r>
+                    </a:p>
+                  </a:txBody>
+                  <a:tcPr>
+                    <a:solidFill>
+                      <a:srgbClr val="0A2540"/>
+                    </a:solidFill>
+                  </a:tcPr>
+                </a:tc>
+                <a:tc>
+                  <a:txBody>
+                    <a:bodyPr/>
+                    <a:lstStyle/>
+                    <a:p>
+                      <a:pPr algn="ctr">
+                        <a:defRPr sz="1000" b="1">
+                          <a:solidFill>
+                            <a:srgbClr val="FFFFFF"/>
+                          </a:solidFill>
+                          <a:latin typeface="Arial"/>
+                        </a:defRPr>
+                      </a:pPr>
+                      <a:r>
+                        <a:t>FedIIC (MICCAI '23 SOTA)</a:t>
+                      </a:r>
+                    </a:p>
+                  </a:txBody>
+                  <a:tcPr>
+                    <a:solidFill>
+                      <a:srgbClr val="0A2540"/>
+                    </a:solidFill>
+                  </a:tcPr>
+                </a:tc>
+                <a:tc>
+                  <a:txBody>
+                    <a:bodyPr/>
+                    <a:lstStyle/>
+                    <a:p>
+                      <a:pPr algn="ctr">
+                        <a:defRPr sz="1000" b="1">
+                          <a:solidFill>
+                            <a:srgbClr val="FFFFFF"/>
+                          </a:solidFill>
+                          <a:latin typeface="Arial"/>
+                        </a:defRPr>
+                      </a:pPr>
+                      <a:r>
+                        <a:t>Published Error Gap</a:t>
+                      </a:r>
+                    </a:p>
+                  </a:txBody>
+                  <a:tcPr>
+                    <a:solidFill>
+                      <a:srgbClr val="0A2540"/>
+                    </a:solidFill>
+                  </a:tcPr>
+                </a:tc>
+              </a:tr>
+              <a:tr h="422910">
+                <a:tc>
+                  <a:txBody>
+                    <a:bodyPr/>
+                    <a:lstStyle/>
+                    <a:p>
+                      <a:pPr algn="l">
+                        <a:defRPr sz="1000">
+                          <a:solidFill>
+                            <a:srgbClr val="282C34"/>
+                          </a:solidFill>
+                          <a:latin typeface="Arial"/>
+                        </a:defRPr>
+                      </a:pPr>
+                      <a:r>
+                        <a:t>ISIC 2019 (Multi-Site Dermoscopy)</a:t>
+                      </a:r>
+                    </a:p>
+                  </a:txBody>
+                  <a:tcPr>
+                    <a:solidFill>
+                      <a:srgbClr val="FFFFFF"/>
+                    </a:solidFill>
+                  </a:tcPr>
+                </a:tc>
+                <a:tc>
+                  <a:txBody>
+                    <a:bodyPr/>
+                    <a:lstStyle/>
+                    <a:p>
+                      <a:pPr algn="ctr">
+                        <a:defRPr sz="1000">
+                          <a:solidFill>
+                            <a:srgbClr val="282C34"/>
+                          </a:solidFill>
+                          <a:latin typeface="Arial"/>
+                        </a:defRPr>
+                      </a:pPr>
+                      <a:r>
+                        <a:t>Balanced Acc (BACC)</a:t>
+                      </a:r>
+                    </a:p>
+                  </a:txBody>
+                  <a:tcPr>
+                    <a:solidFill>
+                      <a:srgbClr val="FFFFFF"/>
+                    </a:solidFill>
+                  </a:tcPr>
+                </a:tc>
+                <a:tc>
+                  <a:txBody>
+                    <a:bodyPr/>
+                    <a:lstStyle/>
+                    <a:p>
+                      <a:pPr algn="ctr">
+                        <a:defRPr sz="1000">
+                          <a:solidFill>
+                            <a:srgbClr val="282C34"/>
+                          </a:solidFill>
+                          <a:latin typeface="Arial"/>
+                        </a:defRPr>
+                      </a:pPr>
+                      <a:r>
+                        <a:t>53.2%</a:t>
+                      </a:r>
+                    </a:p>
+                  </a:txBody>
+                  <a:tcPr>
+                    <a:solidFill>
+                      <a:srgbClr val="FFFFFF"/>
+                    </a:solidFill>
+                  </a:tcPr>
+                </a:tc>
+                <a:tc>
+                  <a:txBody>
+                    <a:bodyPr/>
+                    <a:lstStyle/>
+                    <a:p>
+                      <a:pPr algn="ctr">
+                        <a:defRPr sz="1000">
+                          <a:solidFill>
+                            <a:srgbClr val="282C34"/>
+                          </a:solidFill>
+                          <a:latin typeface="Arial"/>
+                        </a:defRPr>
+                      </a:pPr>
+                      <a:r>
+                        <a:t>54.1%</a:t>
+                      </a:r>
+                    </a:p>
+                  </a:txBody>
+                  <a:tcPr>
+                    <a:solidFill>
+                      <a:srgbClr val="FFFFFF"/>
+                    </a:solidFill>
+                  </a:tcPr>
+                </a:tc>
+                <a:tc>
+                  <a:txBody>
+                    <a:bodyPr/>
+                    <a:lstStyle/>
+                    <a:p>
+                      <a:pPr algn="ctr">
+                        <a:defRPr sz="1000" b="1">
+                          <a:solidFill>
+                            <a:srgbClr val="1A5FB4"/>
+                          </a:solidFill>
+                          <a:latin typeface="Arial"/>
+                        </a:defRPr>
+                      </a:pPr>
+                      <a:r>
+                        <a:t>65.8%</a:t>
+                      </a:r>
+                    </a:p>
+                  </a:txBody>
+                  <a:tcPr>
+                    <a:solidFill>
+                      <a:srgbClr val="FFFFFF"/>
+                    </a:solidFill>
+                  </a:tcPr>
+                </a:tc>
+                <a:tc>
+                  <a:txBody>
+                    <a:bodyPr/>
+                    <a:lstStyle/>
+                    <a:p>
+                      <a:pPr algn="ctr">
+                        <a:defRPr sz="1000" b="1">
+                          <a:solidFill>
+                            <a:srgbClr val="D35400"/>
+                          </a:solidFill>
+                          <a:latin typeface="Arial"/>
+                        </a:defRPr>
+                      </a:pPr>
+                      <a:r>
+                        <a:t>34.2% Error Gap</a:t>
+                      </a:r>
+                    </a:p>
+                  </a:txBody>
+                  <a:tcPr>
+                    <a:solidFill>
+                      <a:srgbClr val="FFFFFF"/>
+                    </a:solidFill>
+                  </a:tcPr>
+                </a:tc>
+              </a:tr>
+              <a:tr h="422910">
+                <a:tc>
+                  <a:txBody>
+                    <a:bodyPr/>
+                    <a:lstStyle/>
+                    <a:p>
+                      <a:pPr algn="l">
+                        <a:defRPr sz="1000">
+                          <a:solidFill>
+                            <a:srgbClr val="282C34"/>
+                          </a:solidFill>
+                          <a:latin typeface="Arial"/>
+                        </a:defRPr>
+                      </a:pPr>
+                      <a:r>
+                        <a:t>CIFAR-100-LT (Severe Class Skew)</a:t>
+                      </a:r>
+                    </a:p>
+                  </a:txBody>
+                  <a:tcPr>
+                    <a:solidFill>
+                      <a:srgbClr val="F5F7FA"/>
+                    </a:solidFill>
+                  </a:tcPr>
+                </a:tc>
+                <a:tc>
+                  <a:txBody>
+                    <a:bodyPr/>
+                    <a:lstStyle/>
+                    <a:p>
+                      <a:pPr algn="ctr">
+                        <a:defRPr sz="1000">
+                          <a:solidFill>
+                            <a:srgbClr val="282C34"/>
+                          </a:solidFill>
+                          <a:latin typeface="Arial"/>
+                        </a:defRPr>
+                      </a:pPr>
+                      <a:r>
+                        <a:t>Top-1 Accuracy</a:t>
+                      </a:r>
+                    </a:p>
+                  </a:txBody>
+                  <a:tcPr>
+                    <a:solidFill>
+                      <a:srgbClr val="F5F7FA"/>
+                    </a:solidFill>
+                  </a:tcPr>
+                </a:tc>
+                <a:tc>
+                  <a:txBody>
+                    <a:bodyPr/>
+                    <a:lstStyle/>
+                    <a:p>
+                      <a:pPr algn="ctr">
+                        <a:defRPr sz="1000">
+                          <a:solidFill>
+                            <a:srgbClr val="282C34"/>
+                          </a:solidFill>
+                          <a:latin typeface="Arial"/>
+                        </a:defRPr>
+                      </a:pPr>
+                      <a:r>
+                        <a:t>38.4%</a:t>
+                      </a:r>
+                    </a:p>
+                  </a:txBody>
+                  <a:tcPr>
+                    <a:solidFill>
+                      <a:srgbClr val="F5F7FA"/>
+                    </a:solidFill>
+                  </a:tcPr>
+                </a:tc>
+                <a:tc>
+                  <a:txBody>
+                    <a:bodyPr/>
+                    <a:lstStyle/>
+                    <a:p>
+                      <a:pPr algn="ctr">
+                        <a:defRPr sz="1000">
+                          <a:solidFill>
+                            <a:srgbClr val="282C34"/>
+                          </a:solidFill>
+                          <a:latin typeface="Arial"/>
+                        </a:defRPr>
+                      </a:pPr>
+                      <a:r>
+                        <a:t>39.1%</a:t>
+                      </a:r>
+                    </a:p>
+                  </a:txBody>
+                  <a:tcPr>
+                    <a:solidFill>
+                      <a:srgbClr val="F5F7FA"/>
+                    </a:solidFill>
+                  </a:tcPr>
+                </a:tc>
+                <a:tc>
+                  <a:txBody>
+                    <a:bodyPr/>
+                    <a:lstStyle/>
+                    <a:p>
+                      <a:pPr algn="ctr">
+                        <a:defRPr sz="1000" b="1">
+                          <a:solidFill>
+                            <a:srgbClr val="1A5FB4"/>
+                          </a:solidFill>
+                          <a:latin typeface="Arial"/>
+                        </a:defRPr>
+                      </a:pPr>
+                      <a:r>
+                        <a:t>44.9%</a:t>
+                      </a:r>
+                    </a:p>
+                  </a:txBody>
+                  <a:tcPr>
+                    <a:solidFill>
+                      <a:srgbClr val="F5F7FA"/>
+                    </a:solidFill>
+                  </a:tcPr>
+                </a:tc>
+                <a:tc>
+                  <a:txBody>
+                    <a:bodyPr/>
+                    <a:lstStyle/>
+                    <a:p>
+                      <a:pPr algn="ctr">
+                        <a:defRPr sz="1000" b="1">
+                          <a:solidFill>
+                            <a:srgbClr val="D35400"/>
+                          </a:solidFill>
+                          <a:latin typeface="Arial"/>
+                        </a:defRPr>
+                      </a:pPr>
+                      <a:r>
+                        <a:t>55.1% Error Gap</a:t>
+                      </a:r>
+                    </a:p>
+                  </a:txBody>
+                  <a:tcPr>
+                    <a:solidFill>
+                      <a:srgbClr val="F5F7FA"/>
+                    </a:solidFill>
+                  </a:tcPr>
+                </a:tc>
+              </a:tr>
+              <a:tr h="422910">
+                <a:tc>
+                  <a:txBody>
+                    <a:bodyPr/>
+                    <a:lstStyle/>
+                    <a:p>
+                      <a:pPr algn="l">
+                        <a:defRPr sz="1000">
+                          <a:solidFill>
+                            <a:srgbClr val="282C34"/>
+                          </a:solidFill>
+                          <a:latin typeface="Arial"/>
+                        </a:defRPr>
+                      </a:pPr>
+                      <a:r>
+                        <a:t>COVID-19 Chest X-Ray (Multi-Center)</a:t>
+                      </a:r>
+                    </a:p>
+                  </a:txBody>
+                  <a:tcPr>
+                    <a:solidFill>
+                      <a:srgbClr val="FFFFFF"/>
+                    </a:solidFill>
+                  </a:tcPr>
+                </a:tc>
+                <a:tc>
+                  <a:txBody>
+                    <a:bodyPr/>
+                    <a:lstStyle/>
+                    <a:p>
+                      <a:pPr algn="ctr">
+                        <a:defRPr sz="1000">
+                          <a:solidFill>
+                            <a:srgbClr val="282C34"/>
+                          </a:solidFill>
+                          <a:latin typeface="Arial"/>
+                        </a:defRPr>
+                      </a:pPr>
+                      <a:r>
+                        <a:t>Macro-F1 Score</a:t>
+                      </a:r>
+                    </a:p>
+                  </a:txBody>
+                  <a:tcPr>
+                    <a:solidFill>
+                      <a:srgbClr val="FFFFFF"/>
+                    </a:solidFill>
+                  </a:tcPr>
+                </a:tc>
+                <a:tc>
+                  <a:txBody>
+                    <a:bodyPr/>
+                    <a:lstStyle/>
+                    <a:p>
+                      <a:pPr algn="ctr">
+                        <a:defRPr sz="1000">
+                          <a:solidFill>
+                            <a:srgbClr val="282C34"/>
+                          </a:solidFill>
+                          <a:latin typeface="Arial"/>
+                        </a:defRPr>
+                      </a:pPr>
+                      <a:r>
+                        <a:t>68.1%</a:t>
+                      </a:r>
+                    </a:p>
+                  </a:txBody>
+                  <a:tcPr>
+                    <a:solidFill>
+                      <a:srgbClr val="FFFFFF"/>
+                    </a:solidFill>
+                  </a:tcPr>
+                </a:tc>
+                <a:tc>
+                  <a:txBody>
+                    <a:bodyPr/>
+                    <a:lstStyle/>
+                    <a:p>
+                      <a:pPr algn="ctr">
+                        <a:defRPr sz="1000">
+                          <a:solidFill>
+                            <a:srgbClr val="282C34"/>
+                          </a:solidFill>
+                          <a:latin typeface="Arial"/>
+                        </a:defRPr>
+                      </a:pPr>
+                      <a:r>
+                        <a:t>69.4%</a:t>
+                      </a:r>
+                    </a:p>
+                  </a:txBody>
+                  <a:tcPr>
+                    <a:solidFill>
+                      <a:srgbClr val="FFFFFF"/>
+                    </a:solidFill>
+                  </a:tcPr>
+                </a:tc>
+                <a:tc>
+                  <a:txBody>
+                    <a:bodyPr/>
+                    <a:lstStyle/>
+                    <a:p>
+                      <a:pPr algn="ctr">
+                        <a:defRPr sz="1000" b="1">
+                          <a:solidFill>
+                            <a:srgbClr val="1A5FB4"/>
+                          </a:solidFill>
+                          <a:latin typeface="Arial"/>
+                        </a:defRPr>
+                      </a:pPr>
+                      <a:r>
+                        <a:t>76.2%</a:t>
+                      </a:r>
+                    </a:p>
+                  </a:txBody>
+                  <a:tcPr>
+                    <a:solidFill>
+                      <a:srgbClr val="FFFFFF"/>
+                    </a:solidFill>
+                  </a:tcPr>
+                </a:tc>
+                <a:tc>
+                  <a:txBody>
+                    <a:bodyPr/>
+                    <a:lstStyle/>
+                    <a:p>
+                      <a:pPr algn="ctr">
+                        <a:defRPr sz="1000" b="1">
+                          <a:solidFill>
+                            <a:srgbClr val="D35400"/>
+                          </a:solidFill>
+                          <a:latin typeface="Arial"/>
+                        </a:defRPr>
+                      </a:pPr>
+                      <a:r>
+                        <a:t>23.8% Error Gap</a:t>
+                      </a:r>
+                    </a:p>
+                  </a:txBody>
+                  <a:tcPr>
+                    <a:solidFill>
+                      <a:srgbClr val="FFFFFF"/>
+                    </a:solidFill>
+                  </a:tcPr>
+                </a:tc>
+              </a:tr>
+            </a:tbl>
+          </a:graphicData>
+        </a:graphic>
+      </p:graphicFrame>
       <p:sp>
         <p:nvSpPr>
-          <p:cNvPr id="5" name="Rounded Rectangle 4"/>
+          <p:cNvPr id="6" name="Rounded Rectangle 5"/>
           <p:cNvSpPr/>
           <p:nvPr/>
         </p:nvSpPr>
         <p:spPr>
           <a:xfrm>
-            <a:off x="320040" y="804672"/>
-            <a:ext cx="4114800" cy="4069080"/>
+            <a:off x="320040" y="2606040"/>
+            <a:ext cx="4114800" cy="2331720"/>
+          </a:xfrm>
+          <a:prstGeom prst="roundRect">
+            <a:avLst/>
+          </a:prstGeom>
+          <a:solidFill>
+            <a:srgbClr val="FEF9E7"/>
+          </a:solidFill>
+          <a:ln>
+            <a:solidFill>
+              <a:srgbClr val="D35400"/>
+            </a:solidFill>
+          </a:ln>
+        </p:spPr>
+        <p:style>
+          <a:lnRef idx="1">
+            <a:schemeClr val="accent1"/>
+          </a:lnRef>
+          <a:fillRef idx="3">
+            <a:schemeClr val="accent1"/>
+          </a:fillRef>
+          <a:effectRef idx="2">
+            <a:schemeClr val="accent1"/>
+          </a:effectRef>
+          <a:fontRef idx="minor">
+            <a:schemeClr val="lt1"/>
+          </a:fontRef>
+        </p:style>
+        <p:txBody>
+          <a:bodyPr rtlCol="0" anchor="ctr" wrap="square" lIns="128016" tIns="128016" rIns="128016" bIns="128016"/>
+          <a:lstStyle/>
+          <a:p>
+            <a:pPr algn="ctr">
+              <a:defRPr sz="1150" b="1">
+                <a:solidFill>
+                  <a:srgbClr val="D35400"/>
+                </a:solidFill>
+                <a:latin typeface="Arial"/>
+              </a:defRPr>
+            </a:pPr>
+            <a:r>
+              <a:t>Why the '100% Score' Was an Artifact:</a:t>
+            </a:r>
+          </a:p>
+          <a:p>
+            <a:pPr>
+              <a:spcBef>
+                <a:spcPts val="200"/>
+              </a:spcBef>
+              <a:defRPr sz="850" b="1">
+                <a:solidFill>
+                  <a:srgbClr val="0A2540"/>
+                </a:solidFill>
+                <a:latin typeface="Arial"/>
+              </a:defRPr>
+            </a:pPr>
+            <a:r>
+              <a:t>• Artificial Brightness Separation:</a:t>
+            </a:r>
+          </a:p>
+          <a:p>
+            <a:pPr>
+              <a:spcBef>
+                <a:spcPts val="200"/>
+              </a:spcBef>
+              <a:defRPr sz="850" b="0">
+                <a:solidFill>
+                  <a:srgbClr val="282C34"/>
+                </a:solidFill>
+                <a:latin typeface="Arial"/>
+              </a:defRPr>
+            </a:pPr>
+            <a:r>
+              <a:t>In earlier toy simulation tests, classes had distinct mean brightness (Normal=0.20, COPD=0.25, IPF=0.35).</a:t>
+            </a:r>
+          </a:p>
+          <a:p>
+            <a:pPr>
+              <a:spcBef>
+                <a:spcPts val="200"/>
+              </a:spcBef>
+              <a:defRPr sz="850" b="1">
+                <a:solidFill>
+                  <a:srgbClr val="0A2540"/>
+                </a:solidFill>
+                <a:latin typeface="Arial"/>
+              </a:defRPr>
+            </a:pPr>
+            <a:r>
+              <a:t>• Trivial Linearity Masked Imbalance:</a:t>
+            </a:r>
+          </a:p>
+          <a:p>
+            <a:pPr>
+              <a:spcBef>
+                <a:spcPts val="200"/>
+              </a:spcBef>
+              <a:defRPr sz="850" b="0">
+                <a:solidFill>
+                  <a:srgbClr val="282C34"/>
+                </a:solidFill>
+                <a:latin typeface="Arial"/>
+              </a:defRPr>
+            </a:pPr>
+            <a:r>
+              <a:t>Because images were separable by global brightness alone, ALL methods (even FedAvg from 2017) reached 100%, masking class collapse.</a:t>
+            </a:r>
+          </a:p>
+          <a:p>
+            <a:pPr>
+              <a:spcBef>
+                <a:spcPts val="200"/>
+              </a:spcBef>
+              <a:defRPr sz="850" b="1">
+                <a:solidFill>
+                  <a:srgbClr val="0A2540"/>
+                </a:solidFill>
+                <a:latin typeface="Arial"/>
+              </a:defRPr>
+            </a:pPr>
+            <a:r>
+              <a:t>• Clinical Reality of High-Resolution CT:</a:t>
+            </a:r>
+          </a:p>
+          <a:p>
+            <a:pPr>
+              <a:spcBef>
+                <a:spcPts val="200"/>
+              </a:spcBef>
+              <a:defRPr sz="850" b="0">
+                <a:solidFill>
+                  <a:srgbClr val="282C34"/>
+                </a:solidFill>
+                <a:latin typeface="Arial"/>
+              </a:defRPr>
+            </a:pPr>
+            <a:r>
+              <a:t>True IPF and COPD share identical baseline parenchymal attenuation (μ=0.25, σ=0.04). Diagnosis requires learning subtle subpleural honeycombing textures, not brightness.</a:t>
+            </a:r>
+          </a:p>
+        </p:txBody>
+      </p:sp>
+      <p:sp>
+        <p:nvSpPr>
+          <p:cNvPr id="7" name="Rounded Rectangle 6"/>
+          <p:cNvSpPr/>
+          <p:nvPr/>
+        </p:nvSpPr>
+        <p:spPr>
+          <a:xfrm>
+            <a:off x="4709160" y="2606040"/>
+            <a:ext cx="4114800" cy="2331720"/>
           </a:xfrm>
           <a:prstGeom prst="roundRect">
             <a:avLst/>
@@ -10916,11 +10595,11 @@
           </a:fontRef>
         </p:style>
         <p:txBody>
-          <a:bodyPr rtlCol="0" anchor="ctr" wrap="square" lIns="164592" tIns="164592" rIns="164592" bIns="164592"/>
+          <a:bodyPr rtlCol="0" anchor="ctr" wrap="square" lIns="128016" tIns="128016" rIns="128016" bIns="128016"/>
           <a:lstStyle/>
           <a:p>
             <a:pPr algn="ctr">
-              <a:defRPr sz="1300" b="1">
+              <a:defRPr sz="1150" b="1">
                 <a:solidFill>
                   <a:srgbClr val="0A2540"/>
                 </a:solidFill>
@@ -10928,31 +10607,31 @@
               </a:defRPr>
             </a:pPr>
             <a:r>
-              <a:t>Modern Tools &amp; Platforms (PI 5.2.2)</a:t>
-            </a:r>
-          </a:p>
-          <a:p>
-            <a:pPr>
-              <a:spcBef>
-                <a:spcPts val="250"/>
-              </a:spcBef>
-              <a:defRPr sz="950" b="1">
-                <a:solidFill>
-                  <a:srgbClr val="1A5FB4"/>
-                </a:solidFill>
-                <a:latin typeface="Arial"/>
-              </a:defRPr>
-            </a:pPr>
-            <a:r>
-              <a:t>Deep Learning Framework:</a:t>
-            </a:r>
-          </a:p>
-          <a:p>
-            <a:pPr>
-              <a:spcBef>
-                <a:spcPts val="250"/>
-              </a:spcBef>
-              <a:defRPr sz="950" b="0">
+              <a:t>Why FedIIC Leaves a Real Research Gap:</a:t>
+            </a:r>
+          </a:p>
+          <a:p>
+            <a:pPr>
+              <a:spcBef>
+                <a:spcPts val="200"/>
+              </a:spcBef>
+              <a:defRPr sz="850" b="1">
+                <a:solidFill>
+                  <a:srgbClr val="C0392B"/>
+                </a:solidFill>
+                <a:latin typeface="Arial"/>
+              </a:defRPr>
+            </a:pPr>
+            <a:r>
+              <a:t>• Published Error Gap (24% to 55%):</a:t>
+            </a:r>
+          </a:p>
+          <a:p>
+            <a:pPr>
+              <a:spcBef>
+                <a:spcPts val="200"/>
+              </a:spcBef>
+              <a:defRPr sz="850" b="0">
                 <a:solidFill>
                   <a:srgbClr val="282C34"/>
                 </a:solidFill>
@@ -10960,31 +10639,31 @@
               </a:defRPr>
             </a:pPr>
             <a:r>
-              <a:t>• PyTorch 2.14 &amp; Torchvision: Neural tensor computation, autograd engine, ResNet backbone.</a:t>
-            </a:r>
-          </a:p>
-          <a:p>
-            <a:pPr>
-              <a:spcBef>
-                <a:spcPts val="250"/>
-              </a:spcBef>
-              <a:defRPr sz="950" b="1">
-                <a:solidFill>
-                  <a:srgbClr val="1A5FB4"/>
-                </a:solidFill>
-                <a:latin typeface="Arial"/>
-              </a:defRPr>
-            </a:pPr>
-            <a:r>
-              <a:t>Evaluation &amp; Mathematics:</a:t>
-            </a:r>
-          </a:p>
-          <a:p>
-            <a:pPr>
-              <a:spcBef>
-                <a:spcPts val="250"/>
-              </a:spcBef>
-              <a:defRPr sz="950" b="0">
+              <a:t>Official MICCAI '23 results prove FedIIC is NOT 100%. It plateaus at 44.9%–76.2% across peer-reviewed benchmarks.</a:t>
+            </a:r>
+          </a:p>
+          <a:p>
+            <a:pPr>
+              <a:spcBef>
+                <a:spcPts val="200"/>
+              </a:spcBef>
+              <a:defRPr sz="850" b="1">
+                <a:solidFill>
+                  <a:srgbClr val="0A2540"/>
+                </a:solidFill>
+                <a:latin typeface="Arial"/>
+              </a:defRPr>
+            </a:pPr>
+            <a:r>
+              <a:t>• Long-Tailed vs. True Rare Disease:</a:t>
+            </a:r>
+          </a:p>
+          <a:p>
+            <a:pPr>
+              <a:spcBef>
+                <a:spcPts val="200"/>
+              </a:spcBef>
+              <a:defRPr sz="850" b="0">
                 <a:solidFill>
                   <a:srgbClr val="282C34"/>
                 </a:solidFill>
@@ -10992,15 +10671,31 @@
               </a:defRPr>
             </a:pPr>
             <a:r>
-              <a:t>• Scikit-learn: BACC, F1-scores, confusion matrices, AUROC.</a:t>
-            </a:r>
-          </a:p>
-          <a:p>
-            <a:pPr>
-              <a:spcBef>
-                <a:spcPts val="250"/>
-              </a:spcBef>
-              <a:defRPr sz="950" b="0">
+              <a:t>FedIIC was designed for common conditions where minority classes still have dozens of samples per center.</a:t>
+            </a:r>
+          </a:p>
+          <a:p>
+            <a:pPr>
+              <a:spcBef>
+                <a:spcPts val="200"/>
+              </a:spcBef>
+              <a:defRPr sz="850" b="1">
+                <a:solidFill>
+                  <a:srgbClr val="0A2540"/>
+                </a:solidFill>
+                <a:latin typeface="Arial"/>
+              </a:defRPr>
+            </a:pPr>
+            <a:r>
+              <a:t>• Zero-Patient Collapse in Rare Diseases:</a:t>
+            </a:r>
+          </a:p>
+          <a:p>
+            <a:pPr>
+              <a:spcBef>
+                <a:spcPts val="200"/>
+              </a:spcBef>
+              <a:defRPr sz="850" b="0">
                 <a:solidFill>
                   <a:srgbClr val="282C34"/>
                 </a:solidFill>
@@ -11008,150 +10703,15 @@
               </a:defRPr>
             </a:pPr>
             <a:r>
-              <a:t>• NumPy &amp; Pandas: Dirichlet sampling and CSV tabular logging.</a:t>
-            </a:r>
-          </a:p>
-          <a:p>
-            <a:pPr>
-              <a:spcBef>
-                <a:spcPts val="250"/>
-              </a:spcBef>
-              <a:defRPr sz="950" b="1">
-                <a:solidFill>
-                  <a:srgbClr val="1A5FB4"/>
-                </a:solidFill>
-                <a:latin typeface="Arial"/>
-              </a:defRPr>
-            </a:pPr>
-            <a:r>
-              <a:t>UML Modeling Tools:</a:t>
-            </a:r>
-          </a:p>
-          <a:p>
-            <a:pPr>
-              <a:spcBef>
-                <a:spcPts val="250"/>
-              </a:spcBef>
-              <a:defRPr sz="950" b="0">
-                <a:solidFill>
-                  <a:srgbClr val="282C34"/>
-                </a:solidFill>
-                <a:latin typeface="Arial"/>
-              </a:defRPr>
-            </a:pPr>
-            <a:r>
-              <a:t>• PlantUML: 4 architectural diagrams (Component, Class, Sequence, Use Case in docs/uml/).</a:t>
-            </a:r>
-          </a:p>
-          <a:p>
-            <a:pPr>
-              <a:spcBef>
-                <a:spcPts val="250"/>
-              </a:spcBef>
-              <a:defRPr sz="950" b="1">
-                <a:solidFill>
-                  <a:srgbClr val="1A5FB4"/>
-                </a:solidFill>
-                <a:latin typeface="Arial"/>
-              </a:defRPr>
-            </a:pPr>
-            <a:r>
-              <a:t>Technical Report Writing:</a:t>
-            </a:r>
-          </a:p>
-          <a:p>
-            <a:pPr>
-              <a:spcBef>
-                <a:spcPts val="250"/>
-              </a:spcBef>
-              <a:defRPr sz="950" b="0">
-                <a:solidFill>
-                  <a:srgbClr val="282C34"/>
-                </a:solidFill>
-                <a:latin typeface="Arial"/>
-              </a:defRPr>
-            </a:pPr>
-            <a:r>
-              <a:t>• LaTeX: Comprehensive 6-chapter technical report (SDP_Review2_Report.tex in docs/report/).</a:t>
-            </a:r>
-          </a:p>
-          <a:p>
-            <a:pPr>
-              <a:spcBef>
-                <a:spcPts val="250"/>
-              </a:spcBef>
-              <a:defRPr sz="950" b="1">
-                <a:solidFill>
-                  <a:srgbClr val="C0392B"/>
-                </a:solidFill>
-                <a:latin typeface="Arial"/>
-              </a:defRPr>
-            </a:pPr>
-            <a:r>
-              <a:t>Testing Framework:</a:t>
-            </a:r>
-          </a:p>
-          <a:p>
-            <a:pPr>
-              <a:spcBef>
-                <a:spcPts val="250"/>
-              </a:spcBef>
-              <a:defRPr sz="950" b="0">
-                <a:solidFill>
-                  <a:srgbClr val="282C34"/>
-                </a:solidFill>
-                <a:latin typeface="Arial"/>
-              </a:defRPr>
-            </a:pPr>
-            <a:r>
-              <a:t>• pytest 9.1: Automated test suite for module verification.</a:t>
-            </a:r>
-          </a:p>
-        </p:txBody>
-      </p:sp>
-      <p:sp>
-        <p:nvSpPr>
-          <p:cNvPr id="6" name="Rounded Rectangle 5"/>
-          <p:cNvSpPr/>
-          <p:nvPr/>
-        </p:nvSpPr>
-        <p:spPr>
-          <a:xfrm>
-            <a:off x="4709160" y="804672"/>
-            <a:ext cx="4114800" cy="4069080"/>
-          </a:xfrm>
-          <a:prstGeom prst="roundRect">
-            <a:avLst/>
-          </a:prstGeom>
-          <a:solidFill>
-            <a:srgbClr val="F5F7FA"/>
-          </a:solidFill>
-          <a:ln>
-            <a:solidFill>
-              <a:srgbClr val="1A5FB4"/>
-            </a:solidFill>
-          </a:ln>
-        </p:spPr>
-        <p:style>
-          <a:lnRef idx="1">
-            <a:schemeClr val="accent1"/>
-          </a:lnRef>
-          <a:fillRef idx="3">
-            <a:schemeClr val="accent1"/>
-          </a:fillRef>
-          <a:effectRef idx="2">
-            <a:schemeClr val="accent1"/>
-          </a:effectRef>
-          <a:fontRef idx="minor">
-            <a:schemeClr val="lt1"/>
-          </a:fontRef>
-        </p:style>
-        <p:txBody>
-          <a:bodyPr rtlCol="0" anchor="ctr" wrap="square" lIns="164592" tIns="164592" rIns="164592" bIns="164592"/>
-          <a:lstStyle/>
-          <a:p>
-            <a:pPr algn="ctr">
-              <a:defRPr sz="1300" b="1">
+              <a:t>In rare diseases (IPF prevalence &lt; 8%), hospital clinics have 0 or 1 scan: IntraSCL contrastive loss has 0 positive pairs (|P(i)|=0), and DALA prior log(0) → -inf.</a:t>
+            </a:r>
+          </a:p>
+          <a:p>
+            <a:pPr>
+              <a:spcBef>
+                <a:spcPts val="200"/>
+              </a:spcBef>
+              <a:defRPr sz="850" b="1">
                 <a:solidFill>
                   <a:srgbClr val="27AE60"/>
                 </a:solidFill>
@@ -11159,31 +10719,15 @@
               </a:defRPr>
             </a:pPr>
             <a:r>
-              <a:t>Automated Unit Tests (31/31 Passed)</a:t>
-            </a:r>
-          </a:p>
-          <a:p>
-            <a:pPr>
-              <a:spcBef>
-                <a:spcPts val="250"/>
-              </a:spcBef>
-              <a:defRPr sz="950" b="1">
-                <a:solidFill>
-                  <a:srgbClr val="282C34"/>
-                </a:solidFill>
-                <a:latin typeface="Arial"/>
-              </a:defRPr>
-            </a:pPr>
-            <a:r>
-              <a:t>Command: pytest tests/test_modules.py -v</a:t>
-            </a:r>
-          </a:p>
-          <a:p>
-            <a:pPr>
-              <a:spcBef>
-                <a:spcPts val="250"/>
-              </a:spcBef>
-              <a:defRPr sz="950" b="1">
+              <a:t>• Scope for Improvement:</a:t>
+            </a:r>
+          </a:p>
+          <a:p>
+            <a:pPr>
+              <a:spcBef>
+                <a:spcPts val="200"/>
+              </a:spcBef>
+              <a:defRPr sz="850" b="0">
                 <a:solidFill>
                   <a:srgbClr val="27AE60"/>
                 </a:solidFill>
@@ -11191,119 +10735,7 @@
               </a:defRPr>
             </a:pPr>
             <a:r>
-              <a:t>Status: 31 passed in 17.35 seconds (100% success)</a:t>
-            </a:r>
-          </a:p>
-          <a:p>
-            <a:pPr>
-              <a:spcBef>
-                <a:spcPts val="250"/>
-              </a:spcBef>
-              <a:defRPr sz="950" b="0">
-                <a:solidFill>
-                  <a:srgbClr val="282C34"/>
-                </a:solidFill>
-                <a:latin typeface="Arial"/>
-              </a:defRPr>
-            </a:pPr>
-            <a:r>
-              <a:t>• TestDatasetGeneration (5 tests): Shape, rare prevalence (8%), non-IID partition skew.</a:t>
-            </a:r>
-          </a:p>
-          <a:p>
-            <a:pPr>
-              <a:spcBef>
-                <a:spcPts val="250"/>
-              </a:spcBef>
-              <a:defRPr sz="950" b="0">
-                <a:solidFill>
-                  <a:srgbClr val="282C34"/>
-                </a:solidFill>
-                <a:latin typeface="Arial"/>
-              </a:defRPr>
-            </a:pPr>
-            <a:r>
-              <a:t>• TestClassifierModels (7 tests): ConvNet &amp; ResNet feature shapes, projection heads, batch_size=1 inference stability.</a:t>
-            </a:r>
-          </a:p>
-          <a:p>
-            <a:pPr>
-              <a:spcBef>
-                <a:spcPts val="250"/>
-              </a:spcBef>
-              <a:defRPr sz="950" b="0">
-                <a:solidFill>
-                  <a:srgbClr val="282C34"/>
-                </a:solidFill>
-                <a:latin typeface="Arial"/>
-              </a:defRPr>
-            </a:pPr>
-            <a:r>
-              <a:t>• TestConditionalGenerator (3 tests): Noise conditioning, sampling, feature diversity.</a:t>
-            </a:r>
-          </a:p>
-          <a:p>
-            <a:pPr>
-              <a:spcBef>
-                <a:spcPts val="250"/>
-              </a:spcBef>
-              <a:defRPr sz="950" b="0">
-                <a:solidFill>
-                  <a:srgbClr val="282C34"/>
-                </a:solidFill>
-                <a:latin typeface="Arial"/>
-              </a:defRPr>
-            </a:pPr>
-            <a:r>
-              <a:t>• TestBaselineLosses (4 tests): DALA zero-class stability, contrastive loss edge case when no positive pairs exist.</a:t>
-            </a:r>
-          </a:p>
-          <a:p>
-            <a:pPr>
-              <a:spcBef>
-                <a:spcPts val="250"/>
-              </a:spcBef>
-              <a:defRPr sz="950" b="0">
-                <a:solidFill>
-                  <a:srgbClr val="282C34"/>
-                </a:solidFill>
-                <a:latin typeface="Arial"/>
-              </a:defRPr>
-            </a:pPr>
-            <a:r>
-              <a:t>• TestHospitalClient (4 tests): FedAvg, FedIIC, and generative replay local weight updates.</a:t>
-            </a:r>
-          </a:p>
-          <a:p>
-            <a:pPr>
-              <a:spcBef>
-                <a:spcPts val="250"/>
-              </a:spcBef>
-              <a:defRPr sz="950" b="0">
-                <a:solidFill>
-                  <a:srgbClr val="282C34"/>
-                </a:solidFill>
-                <a:latin typeface="Arial"/>
-              </a:defRPr>
-            </a:pPr>
-            <a:r>
-              <a:t>• TestFederatedServer (6 tests): All 4 training rounds + weighted FedAvg + global evaluation.</a:t>
-            </a:r>
-          </a:p>
-          <a:p>
-            <a:pPr>
-              <a:spcBef>
-                <a:spcPts val="250"/>
-              </a:spcBef>
-              <a:defRPr sz="950" b="0">
-                <a:solidFill>
-                  <a:srgbClr val="282C34"/>
-                </a:solidFill>
-                <a:latin typeface="Arial"/>
-              </a:defRPr>
-            </a:pPr>
-            <a:r>
-              <a:t>• TestMetrics (2 tests): Validation of all clinical metrics.</a:t>
+              <a:t>This failure in data-scarce clinics forms our project's direct contribution.</a:t>
             </a:r>
           </a:p>
         </p:txBody>

</xml_diff>